<commit_message>
test: render and visually verify presentation package
</commit_message>
<xml_diff>
--- a/outputs/zw1f25_MATH6185_presentation/zw1f25_MATH6185_Presentation.pptx
+++ b/outputs/zw1f25_MATH6185_presentation/zw1f25_MATH6185_Presentation.pptx
@@ -2,124 +2,29 @@
 <file path=ppt/presentation.xml><?xml version="1.0" encoding="utf-8"?>
 <p:presentation xmlns:p="http://schemas.openxmlformats.org/presentationml/2006/main">
   <p:sldMasterIdLst>
-    <p:sldMasterId xmlns:r="http://schemas.openxmlformats.org/officeDocument/2006/relationships" id="2147483648" r:id="Rd57e7df567014e93"/>
+    <p:sldMasterId xmlns:r="http://schemas.openxmlformats.org/officeDocument/2006/relationships" id="2147483648" r:id="Rad2686231d48414c"/>
   </p:sldMasterIdLst>
   <p:notesMasterIdLst>
-    <p:notesMasterId xmlns:r="http://schemas.openxmlformats.org/officeDocument/2006/relationships" r:id="Rbd44702c37bf43bf"/>
+    <p:notesMasterId xmlns:r="http://schemas.openxmlformats.org/officeDocument/2006/relationships" r:id="R1ba61845c15a4ca4"/>
   </p:notesMasterIdLst>
   <p:sldIdLst>
-    <p:sldId xmlns:r="http://schemas.openxmlformats.org/officeDocument/2006/relationships" id="256" r:id="R19ff154fdadd41fe"/>
-    <p:sldId xmlns:r="http://schemas.openxmlformats.org/officeDocument/2006/relationships" id="257" r:id="R1100d8b8bb0e4f99"/>
-    <p:sldId xmlns:r="http://schemas.openxmlformats.org/officeDocument/2006/relationships" id="258" r:id="R9f9268eb698e4a82"/>
-    <p:sldId xmlns:r="http://schemas.openxmlformats.org/officeDocument/2006/relationships" id="259" r:id="R68980aed87904a15"/>
-    <p:sldId xmlns:r="http://schemas.openxmlformats.org/officeDocument/2006/relationships" id="260" r:id="R54c420e78fbc4480"/>
-    <p:sldId xmlns:r="http://schemas.openxmlformats.org/officeDocument/2006/relationships" id="261" r:id="R4615041b3ca14daa"/>
-    <p:sldId xmlns:r="http://schemas.openxmlformats.org/officeDocument/2006/relationships" id="262" r:id="R8f84b1d7089248c7"/>
-    <p:sldId xmlns:r="http://schemas.openxmlformats.org/officeDocument/2006/relationships" id="263" r:id="Rcdfeb59046064328"/>
-    <p:sldId xmlns:r="http://schemas.openxmlformats.org/officeDocument/2006/relationships" id="264" r:id="R3d0931aa90ca4fd6"/>
-    <p:sldId xmlns:r="http://schemas.openxmlformats.org/officeDocument/2006/relationships" id="265" r:id="Re2397c6ffed74c94"/>
-    <p:sldId xmlns:r="http://schemas.openxmlformats.org/officeDocument/2006/relationships" id="266" r:id="Rf93e0a418c11420f"/>
-    <p:sldId xmlns:r="http://schemas.openxmlformats.org/officeDocument/2006/relationships" id="267" r:id="R1e0fa7bda7ee4bc4"/>
-    <p:sldId xmlns:r="http://schemas.openxmlformats.org/officeDocument/2006/relationships" id="268" r:id="R15c6e4a6397a4e0e"/>
-    <p:sldId xmlns:r="http://schemas.openxmlformats.org/officeDocument/2006/relationships" id="269" r:id="R9ce3461254ad4789"/>
+    <p:sldId xmlns:r="http://schemas.openxmlformats.org/officeDocument/2006/relationships" id="256" r:id="R1238a6e8b6784a3c"/>
+    <p:sldId xmlns:r="http://schemas.openxmlformats.org/officeDocument/2006/relationships" id="257" r:id="Rb4ec38084abc45c7"/>
+    <p:sldId xmlns:r="http://schemas.openxmlformats.org/officeDocument/2006/relationships" id="258" r:id="R8b74978eed7f48ab"/>
+    <p:sldId xmlns:r="http://schemas.openxmlformats.org/officeDocument/2006/relationships" id="259" r:id="R125ad4cd32034839"/>
+    <p:sldId xmlns:r="http://schemas.openxmlformats.org/officeDocument/2006/relationships" id="260" r:id="R9fba14caa8e648d9"/>
+    <p:sldId xmlns:r="http://schemas.openxmlformats.org/officeDocument/2006/relationships" id="261" r:id="Rf2c150fa0e9a4380"/>
+    <p:sldId xmlns:r="http://schemas.openxmlformats.org/officeDocument/2006/relationships" id="262" r:id="R5637e4c3efc34fbc"/>
+    <p:sldId xmlns:r="http://schemas.openxmlformats.org/officeDocument/2006/relationships" id="263" r:id="Rf039bebf0b824c70"/>
+    <p:sldId xmlns:r="http://schemas.openxmlformats.org/officeDocument/2006/relationships" id="264" r:id="R7eca81657ca04483"/>
+    <p:sldId xmlns:r="http://schemas.openxmlformats.org/officeDocument/2006/relationships" id="265" r:id="R018bd91ac2434cab"/>
+    <p:sldId xmlns:r="http://schemas.openxmlformats.org/officeDocument/2006/relationships" id="266" r:id="R40bf23159abe497a"/>
+    <p:sldId xmlns:r="http://schemas.openxmlformats.org/officeDocument/2006/relationships" id="267" r:id="R49b71bc722a749e7"/>
+    <p:sldId xmlns:r="http://schemas.openxmlformats.org/officeDocument/2006/relationships" id="268" r:id="Rf5a3d85ce8844e69"/>
+    <p:sldId xmlns:r="http://schemas.openxmlformats.org/officeDocument/2006/relationships" id="269" r:id="Rbd659914e51f4d01"/>
   </p:sldIdLst>
   <p:sldSz cx="12192000" cy="6858000"/>
   <p:notesSz cx="6858000" cy="9144000"/>
-  <p:defaultTextStyle>
-    <a:defPPr xmlns:a="http://schemas.openxmlformats.org/drawingml/2006/main">
-      <a:defRPr lang="en-US"/>
-    </a:defPPr>
-    <a:lvl1pPr xmlns:a="http://schemas.openxmlformats.org/drawingml/2006/main" marL="0" indent="0" algn="l" defTabSz="914400">
-      <a:defRPr sz="1800" kern="1200">
-        <a:solidFill>
-          <a:schemeClr val="tx1"/>
-        </a:solidFill>
-        <a:latin typeface="+mn-lt"/>
-        <a:ea typeface="+mn-ea"/>
-        <a:cs typeface="+mn-cs"/>
-      </a:defRPr>
-    </a:lvl1pPr>
-    <a:lvl2pPr xmlns:a="http://schemas.openxmlformats.org/drawingml/2006/main" marL="457200" indent="0" algn="l" defTabSz="914400">
-      <a:defRPr sz="1800" kern="1200">
-        <a:solidFill>
-          <a:schemeClr val="tx1"/>
-        </a:solidFill>
-        <a:latin typeface="+mn-lt"/>
-        <a:ea typeface="+mn-ea"/>
-        <a:cs typeface="+mn-cs"/>
-      </a:defRPr>
-    </a:lvl2pPr>
-    <a:lvl3pPr xmlns:a="http://schemas.openxmlformats.org/drawingml/2006/main" marL="914400" indent="0" algn="l" defTabSz="914400">
-      <a:defRPr sz="1800" kern="1200">
-        <a:solidFill>
-          <a:schemeClr val="tx1"/>
-        </a:solidFill>
-        <a:latin typeface="+mn-lt"/>
-        <a:ea typeface="+mn-ea"/>
-        <a:cs typeface="+mn-cs"/>
-      </a:defRPr>
-    </a:lvl3pPr>
-    <a:lvl4pPr xmlns:a="http://schemas.openxmlformats.org/drawingml/2006/main" marL="1371600" indent="0" algn="l" defTabSz="914400">
-      <a:defRPr sz="1800" kern="1200">
-        <a:solidFill>
-          <a:schemeClr val="tx1"/>
-        </a:solidFill>
-        <a:latin typeface="+mn-lt"/>
-        <a:ea typeface="+mn-ea"/>
-        <a:cs typeface="+mn-cs"/>
-      </a:defRPr>
-    </a:lvl4pPr>
-    <a:lvl5pPr xmlns:a="http://schemas.openxmlformats.org/drawingml/2006/main" marL="1828800" indent="0" algn="l" defTabSz="914400">
-      <a:defRPr sz="1800" kern="1200">
-        <a:solidFill>
-          <a:schemeClr val="tx1"/>
-        </a:solidFill>
-        <a:latin typeface="+mn-lt"/>
-        <a:ea typeface="+mn-ea"/>
-        <a:cs typeface="+mn-cs"/>
-      </a:defRPr>
-    </a:lvl5pPr>
-    <a:lvl6pPr xmlns:a="http://schemas.openxmlformats.org/drawingml/2006/main" marL="2286000" indent="0" algn="l" defTabSz="914400">
-      <a:defRPr sz="1800" kern="1200">
-        <a:solidFill>
-          <a:schemeClr val="tx1"/>
-        </a:solidFill>
-        <a:latin typeface="+mn-lt"/>
-        <a:ea typeface="+mn-ea"/>
-        <a:cs typeface="+mn-cs"/>
-      </a:defRPr>
-    </a:lvl6pPr>
-    <a:lvl7pPr xmlns:a="http://schemas.openxmlformats.org/drawingml/2006/main" marL="2743200" indent="0" algn="l" defTabSz="914400">
-      <a:defRPr sz="1800" kern="1200">
-        <a:solidFill>
-          <a:schemeClr val="tx1"/>
-        </a:solidFill>
-        <a:latin typeface="+mn-lt"/>
-        <a:ea typeface="+mn-ea"/>
-        <a:cs typeface="+mn-cs"/>
-      </a:defRPr>
-    </a:lvl7pPr>
-    <a:lvl8pPr xmlns:a="http://schemas.openxmlformats.org/drawingml/2006/main" marL="3200400" indent="0" algn="l" defTabSz="914400">
-      <a:defRPr sz="1800" kern="1200">
-        <a:solidFill>
-          <a:schemeClr val="tx1"/>
-        </a:solidFill>
-        <a:latin typeface="+mn-lt"/>
-        <a:ea typeface="+mn-ea"/>
-        <a:cs typeface="+mn-cs"/>
-      </a:defRPr>
-    </a:lvl8pPr>
-    <a:lvl9pPr xmlns:a="http://schemas.openxmlformats.org/drawingml/2006/main" marL="3657600" indent="0" algn="l" defTabSz="914400">
-      <a:defRPr sz="1800" kern="1200">
-        <a:solidFill>
-          <a:schemeClr val="tx1"/>
-        </a:solidFill>
-        <a:latin typeface="+mn-lt"/>
-        <a:ea typeface="+mn-ea"/>
-        <a:cs typeface="+mn-cs"/>
-      </a:defRPr>
-    </a:lvl9pPr>
-  </p:defaultTextStyle>
 </p:presentation>
 </file>
 
@@ -1528,7 +1433,7 @@
   </p:cSld>
   <p:clrMap bg1="lt1" tx1="dk1" bg2="lt2" tx2="dk2" accent1="accent1" accent2="accent2" accent3="accent3" accent4="accent4" accent5="accent5" accent6="accent6" hlink="hlink" folHlink="folHlink"/>
   <p:sldLayoutIdLst>
-    <p:sldLayoutId xmlns:r="http://schemas.openxmlformats.org/officeDocument/2006/relationships" id="2147483649" r:id="R8286723f7e364c36"/>
+    <p:sldLayoutId xmlns:r="http://schemas.openxmlformats.org/officeDocument/2006/relationships" id="2147483649" r:id="R998272dece9948c3"/>
   </p:sldLayoutIdLst>
   <p:txStyles>
     <p:titleStyle>
@@ -2269,40 +2174,10 @@
             </a:ln>
           </c:spPr>
         </c:majorGridlines>
-        <c:title>
-          <c:tx>
-            <c:rich>
-              <a:bodyPr xmlns:a="http://schemas.openxmlformats.org/drawingml/2006/main"/>
-              <a:lstStyle xmlns:a="http://schemas.openxmlformats.org/drawingml/2006/main"/>
-              <a:p xmlns:a="http://schemas.openxmlformats.org/drawingml/2006/main">
-                <a:r>
-                  <a:rPr sz="1200">
-                    <a:solidFill>
-                      <a:srgbClr val="687783"/>
-                    </a:solidFill>
-                  </a:rPr>
-                  <a:t>Mean waiting time (days)</a:t>
-                </a:r>
-              </a:p>
-            </c:rich>
-          </c:tx>
-          <c:txPr>
-            <a:bodyPr xmlns:a="http://schemas.openxmlformats.org/drawingml/2006/main" anchorCtr="1"/>
-            <a:lstStyle xmlns:a="http://schemas.openxmlformats.org/drawingml/2006/main"/>
-            <a:p xmlns:a="http://schemas.openxmlformats.org/drawingml/2006/main">
-              <a:pPr>
-                <a:defRPr sz="1200">
-                  <a:solidFill>
-                    <a:srgbClr val="687783"/>
-                  </a:solidFill>
-                </a:defRPr>
-              </a:pPr>
-            </a:p>
-          </c:txPr>
-        </c:title>
-        <c:numFmt formatCode="General"/>
+        <c:numFmt formatCode="0"/>
         <c:majorTickMark val="none"/>
         <c:minorTickMark val="none"/>
+        <c:tickLblPos val="none"/>
         <c:spPr>
           <a:ln xmlns:a="http://schemas.openxmlformats.org/drawingml/2006/main" w="9525">
             <a:solidFill>
@@ -2316,9 +2191,9 @@
           <a:lstStyle xmlns:a="http://schemas.openxmlformats.org/drawingml/2006/main"/>
           <a:p xmlns:a="http://schemas.openxmlformats.org/drawingml/2006/main">
             <a:pPr>
-              <a:defRPr sz="1125">
-                <a:solidFill>
-                  <a:srgbClr val="687783"/>
+              <a:defRPr>
+                <a:solidFill>
+                  <a:srgbClr val="666666"/>
                 </a:solidFill>
               </a:defRPr>
             </a:pPr>
@@ -2393,7 +2268,7 @@
           <p:cNvPr id="11" name="">
             <a:extLst xmlns:a="http://schemas.openxmlformats.org/drawingml/2006/main">
               <a:ext uri="{FF2B5EF4-FFF2-40B4-BE49-F238E27FC236}">
-                <a16:creationId xmlns:a16="http://schemas.microsoft.com/office/drawing/2014/main" id="{737296AD-E86F-4C78-9D42-17A806ABA512}"/>
+                <a16:creationId xmlns:a16="http://schemas.microsoft.com/office/drawing/2014/main" id="{54155BE2-E33D-40D4-8806-03F58661C094}"/>
               </a:ext>
             </a:extLst>
           </p:cNvPr>
@@ -2424,7 +2299,7 @@
           <p:cNvPr id="2" name="">
             <a:extLst xmlns:a="http://schemas.openxmlformats.org/drawingml/2006/main">
               <a:ext uri="{FF2B5EF4-FFF2-40B4-BE49-F238E27FC236}">
-                <a16:creationId xmlns:a16="http://schemas.microsoft.com/office/drawing/2014/main" id="{4AB7D0FE-6405-44DD-AE27-C603AC7F0FA9}"/>
+                <a16:creationId xmlns:a16="http://schemas.microsoft.com/office/drawing/2014/main" id="{62581255-7B70-4E11-8079-C6819955A67D}"/>
               </a:ext>
             </a:extLst>
           </p:cNvPr>
@@ -2480,7 +2355,7 @@
           <p:cNvPr id="3" name="">
             <a:extLst xmlns:a="http://schemas.openxmlformats.org/drawingml/2006/main">
               <a:ext uri="{FF2B5EF4-FFF2-40B4-BE49-F238E27FC236}">
-                <a16:creationId xmlns:a16="http://schemas.microsoft.com/office/drawing/2014/main" id="{41C75796-F66E-43BB-8577-872B9949D47B}"/>
+                <a16:creationId xmlns:a16="http://schemas.microsoft.com/office/drawing/2014/main" id="{B970B861-1AB5-4782-9A75-B627B3EDB0F2}"/>
               </a:ext>
             </a:extLst>
           </p:cNvPr>
@@ -2559,7 +2434,7 @@
           <p:cNvPr id="4" name="">
             <a:extLst xmlns:a="http://schemas.openxmlformats.org/drawingml/2006/main">
               <a:ext uri="{FF2B5EF4-FFF2-40B4-BE49-F238E27FC236}">
-                <a16:creationId xmlns:a16="http://schemas.microsoft.com/office/drawing/2014/main" id="{8DE1F21F-E04A-4780-AB0E-8B39FB3CE296}"/>
+                <a16:creationId xmlns:a16="http://schemas.microsoft.com/office/drawing/2014/main" id="{7C9126CF-4577-42F7-AE0A-571C5E618F53}"/>
               </a:ext>
             </a:extLst>
           </p:cNvPr>
@@ -2615,7 +2490,7 @@
           <p:cNvPr id="5" name="">
             <a:extLst xmlns:a="http://schemas.openxmlformats.org/drawingml/2006/main">
               <a:ext uri="{FF2B5EF4-FFF2-40B4-BE49-F238E27FC236}">
-                <a16:creationId xmlns:a16="http://schemas.microsoft.com/office/drawing/2014/main" id="{2861DC66-5A9D-4A41-ABAF-7E3288781999}"/>
+                <a16:creationId xmlns:a16="http://schemas.microsoft.com/office/drawing/2014/main" id="{75F2461A-CAA3-43D4-8282-2DD3A09E04BF}"/>
               </a:ext>
             </a:extLst>
           </p:cNvPr>
@@ -2648,7 +2523,7 @@
           <p:cNvPr id="6" name="">
             <a:extLst xmlns:a="http://schemas.openxmlformats.org/drawingml/2006/main">
               <a:ext uri="{FF2B5EF4-FFF2-40B4-BE49-F238E27FC236}">
-                <a16:creationId xmlns:a16="http://schemas.microsoft.com/office/drawing/2014/main" id="{8998DEC7-A6CF-408C-A78F-6A66A9831CBB}"/>
+                <a16:creationId xmlns:a16="http://schemas.microsoft.com/office/drawing/2014/main" id="{8128753E-867B-47DC-9103-07FF0721F618}"/>
               </a:ext>
             </a:extLst>
           </p:cNvPr>
@@ -2704,7 +2579,7 @@
           <p:cNvPr id="7" name="">
             <a:extLst xmlns:a="http://schemas.openxmlformats.org/drawingml/2006/main">
               <a:ext uri="{FF2B5EF4-FFF2-40B4-BE49-F238E27FC236}">
-                <a16:creationId xmlns:a16="http://schemas.microsoft.com/office/drawing/2014/main" id="{3A490C35-877B-4E77-84E1-F3105F8A6C78}"/>
+                <a16:creationId xmlns:a16="http://schemas.microsoft.com/office/drawing/2014/main" id="{FE8BAAD3-7216-4C3C-8A14-998EDE5E6792}"/>
               </a:ext>
             </a:extLst>
           </p:cNvPr>
@@ -2783,7 +2658,7 @@
           <p:cNvPr id="8" name="">
             <a:extLst xmlns:a="http://schemas.openxmlformats.org/drawingml/2006/main">
               <a:ext uri="{FF2B5EF4-FFF2-40B4-BE49-F238E27FC236}">
-                <a16:creationId xmlns:a16="http://schemas.microsoft.com/office/drawing/2014/main" id="{8018B99F-2D48-474C-BDE1-8E5E59FFD03E}"/>
+                <a16:creationId xmlns:a16="http://schemas.microsoft.com/office/drawing/2014/main" id="{1AB6D327-0A4F-408C-9B03-291142258C0F}"/>
               </a:ext>
             </a:extLst>
           </p:cNvPr>
@@ -2814,7 +2689,7 @@
           <p:cNvPr id="9" name="">
             <a:extLst xmlns:a="http://schemas.openxmlformats.org/drawingml/2006/main">
               <a:ext uri="{FF2B5EF4-FFF2-40B4-BE49-F238E27FC236}">
-                <a16:creationId xmlns:a16="http://schemas.microsoft.com/office/drawing/2014/main" id="{90820B81-578D-4020-A795-6EC870A54D9F}"/>
+                <a16:creationId xmlns:a16="http://schemas.microsoft.com/office/drawing/2014/main" id="{5647AE75-8B7B-4E99-A90F-210E3C3A44B3}"/>
               </a:ext>
             </a:extLst>
           </p:cNvPr>
@@ -2893,7 +2768,7 @@
           <p:cNvPr id="10" name="">
             <a:extLst xmlns:a="http://schemas.openxmlformats.org/drawingml/2006/main">
               <a:ext uri="{FF2B5EF4-FFF2-40B4-BE49-F238E27FC236}">
-                <a16:creationId xmlns:a16="http://schemas.microsoft.com/office/drawing/2014/main" id="{5B5957FC-6B17-44B2-9A9F-998570062670}"/>
+                <a16:creationId xmlns:a16="http://schemas.microsoft.com/office/drawing/2014/main" id="{66148EBC-4999-4756-897E-DDDEF5DCE484}"/>
               </a:ext>
             </a:extLst>
           </p:cNvPr>
@@ -2947,7 +2822,7 @@
     </p:spTree>
     <p:extLst>
       <p:ext uri="{BB962C8B-B14F-4D97-AF65-F5344CB8AC3E}">
-        <p14:creationId xmlns:p14="http://schemas.microsoft.com/office/powerpoint/2010/main" val="892823940"/>
+        <p14:creationId xmlns:p14="http://schemas.microsoft.com/office/powerpoint/2010/main" val="527868111"/>
       </p:ext>
     </p:extLst>
   </p:cSld>
@@ -2978,7 +2853,7 @@
           <p:cNvPr id="9" name="slide-title">
             <a:extLst xmlns:a="http://schemas.openxmlformats.org/drawingml/2006/main">
               <a:ext uri="{FF2B5EF4-FFF2-40B4-BE49-F238E27FC236}">
-                <a16:creationId xmlns:a16="http://schemas.microsoft.com/office/drawing/2014/main" id="{923E24F7-7F24-4E27-9AE9-67F869699931}"/>
+                <a16:creationId xmlns:a16="http://schemas.microsoft.com/office/drawing/2014/main" id="{D73B36BE-6D86-4A5C-9817-1D874D50EC69}"/>
               </a:ext>
             </a:extLst>
           </p:cNvPr>
@@ -3034,7 +2909,7 @@
           <p:cNvPr id="2" name="backup-label">
             <a:extLst xmlns:a="http://schemas.openxmlformats.org/drawingml/2006/main">
               <a:ext uri="{FF2B5EF4-FFF2-40B4-BE49-F238E27FC236}">
-                <a16:creationId xmlns:a16="http://schemas.microsoft.com/office/drawing/2014/main" id="{F0EE84C7-4E93-4D2B-984D-99DBED138AC6}"/>
+                <a16:creationId xmlns:a16="http://schemas.microsoft.com/office/drawing/2014/main" id="{F91F4E91-B1E1-4F44-9951-FB4E0467DAD3}"/>
               </a:ext>
             </a:extLst>
           </p:cNvPr>
@@ -3094,7 +2969,7 @@
           <p:cNvPr id="3" name="">
             <a:extLst xmlns:a="http://schemas.openxmlformats.org/drawingml/2006/main">
               <a:ext uri="{FF2B5EF4-FFF2-40B4-BE49-F238E27FC236}">
-                <a16:creationId xmlns:a16="http://schemas.microsoft.com/office/drawing/2014/main" id="{AA822669-4406-4B7E-9C6D-08B655970E4B}"/>
+                <a16:creationId xmlns:a16="http://schemas.microsoft.com/office/drawing/2014/main" id="{C75DBC27-C39B-4D58-A9D8-4EC67143AE04}"/>
               </a:ext>
             </a:extLst>
           </p:cNvPr>
@@ -3384,7 +3259,7 @@
           <p:cNvPr id="5" name="">
             <a:extLst xmlns:a="http://schemas.openxmlformats.org/drawingml/2006/main">
               <a:ext uri="{FF2B5EF4-FFF2-40B4-BE49-F238E27FC236}">
-                <a16:creationId xmlns:a16="http://schemas.microsoft.com/office/drawing/2014/main" id="{92F50E10-706E-4FE5-B1F7-72CB64D5D5CB}"/>
+                <a16:creationId xmlns:a16="http://schemas.microsoft.com/office/drawing/2014/main" id="{63BF0873-2400-48BD-A7B1-65D2124E1087}"/>
               </a:ext>
             </a:extLst>
           </p:cNvPr>
@@ -3444,7 +3319,7 @@
           <p:cNvPr id="6" name="">
             <a:extLst xmlns:a="http://schemas.openxmlformats.org/drawingml/2006/main">
               <a:ext uri="{FF2B5EF4-FFF2-40B4-BE49-F238E27FC236}">
-                <a16:creationId xmlns:a16="http://schemas.microsoft.com/office/drawing/2014/main" id="{61E197CD-8D6C-4916-BB77-CB06E963EE30}"/>
+                <a16:creationId xmlns:a16="http://schemas.microsoft.com/office/drawing/2014/main" id="{DD3887C6-8CA2-4484-9BC1-4575820E2982}"/>
               </a:ext>
             </a:extLst>
           </p:cNvPr>
@@ -3475,7 +3350,7 @@
           <p:cNvPr id="7" name="source-footer">
             <a:extLst xmlns:a="http://schemas.openxmlformats.org/drawingml/2006/main">
               <a:ext uri="{FF2B5EF4-FFF2-40B4-BE49-F238E27FC236}">
-                <a16:creationId xmlns:a16="http://schemas.microsoft.com/office/drawing/2014/main" id="{4CA864F3-B20C-4269-820C-45EAE9B02581}"/>
+                <a16:creationId xmlns:a16="http://schemas.microsoft.com/office/drawing/2014/main" id="{882996D2-7D2A-43C8-AAC9-F74129D44168}"/>
               </a:ext>
             </a:extLst>
           </p:cNvPr>
@@ -3531,7 +3406,7 @@
           <p:cNvPr id="8" name="slide-number">
             <a:extLst xmlns:a="http://schemas.openxmlformats.org/drawingml/2006/main">
               <a:ext uri="{FF2B5EF4-FFF2-40B4-BE49-F238E27FC236}">
-                <a16:creationId xmlns:a16="http://schemas.microsoft.com/office/drawing/2014/main" id="{6A3EACFE-4BB6-428E-9884-075F402A9CEA}"/>
+                <a16:creationId xmlns:a16="http://schemas.microsoft.com/office/drawing/2014/main" id="{1BA1FD08-FAA4-4D2E-9986-333195C0D796}"/>
               </a:ext>
             </a:extLst>
           </p:cNvPr>
@@ -3585,7 +3460,7 @@
     </p:spTree>
     <p:extLst>
       <p:ext uri="{BB962C8B-B14F-4D97-AF65-F5344CB8AC3E}">
-        <p14:creationId xmlns:p14="http://schemas.microsoft.com/office/powerpoint/2010/main" val="1257973997"/>
+        <p14:creationId xmlns:p14="http://schemas.microsoft.com/office/powerpoint/2010/main" val="1000889185"/>
       </p:ext>
     </p:extLst>
   </p:cSld>
@@ -3616,7 +3491,7 @@
           <p:cNvPr id="18" name="slide-title">
             <a:extLst xmlns:a="http://schemas.openxmlformats.org/drawingml/2006/main">
               <a:ext uri="{FF2B5EF4-FFF2-40B4-BE49-F238E27FC236}">
-                <a16:creationId xmlns:a16="http://schemas.microsoft.com/office/drawing/2014/main" id="{5AB160B0-40FD-4903-B358-913629F2D660}"/>
+                <a16:creationId xmlns:a16="http://schemas.microsoft.com/office/drawing/2014/main" id="{AF1FAF06-6B99-446C-81AA-B3580DC6BA9B}"/>
               </a:ext>
             </a:extLst>
           </p:cNvPr>
@@ -3672,7 +3547,7 @@
           <p:cNvPr id="2" name="backup-label">
             <a:extLst xmlns:a="http://schemas.openxmlformats.org/drawingml/2006/main">
               <a:ext uri="{FF2B5EF4-FFF2-40B4-BE49-F238E27FC236}">
-                <a16:creationId xmlns:a16="http://schemas.microsoft.com/office/drawing/2014/main" id="{9C714446-DBD9-4DD8-9633-0443CE9BF5B5}"/>
+                <a16:creationId xmlns:a16="http://schemas.microsoft.com/office/drawing/2014/main" id="{ECA26747-CB65-4BC1-94F5-C2E4B438B0B1}"/>
               </a:ext>
             </a:extLst>
           </p:cNvPr>
@@ -3732,7 +3607,7 @@
           <p:cNvPr id="3" name="">
             <a:extLst xmlns:a="http://schemas.openxmlformats.org/drawingml/2006/main">
               <a:ext uri="{FF2B5EF4-FFF2-40B4-BE49-F238E27FC236}">
-                <a16:creationId xmlns:a16="http://schemas.microsoft.com/office/drawing/2014/main" id="{8971ACE0-D18A-417E-8DDA-FF990CA868A5}"/>
+                <a16:creationId xmlns:a16="http://schemas.microsoft.com/office/drawing/2014/main" id="{ECC14CC6-AA4F-44AD-B903-52F0DAFCEAD1}"/>
               </a:ext>
             </a:extLst>
           </p:cNvPr>
@@ -3763,7 +3638,7 @@
           <p:cNvPr id="4" name="">
             <a:extLst xmlns:a="http://schemas.openxmlformats.org/drawingml/2006/main">
               <a:ext uri="{FF2B5EF4-FFF2-40B4-BE49-F238E27FC236}">
-                <a16:creationId xmlns:a16="http://schemas.microsoft.com/office/drawing/2014/main" id="{41F306CB-7123-43A0-A45B-25E23679D696}"/>
+                <a16:creationId xmlns:a16="http://schemas.microsoft.com/office/drawing/2014/main" id="{34E0F17C-4B00-4803-8549-875041CAFB3C}"/>
               </a:ext>
             </a:extLst>
           </p:cNvPr>
@@ -3796,7 +3671,7 @@
           <p:cNvPr id="5" name="">
             <a:extLst xmlns:a="http://schemas.openxmlformats.org/drawingml/2006/main">
               <a:ext uri="{FF2B5EF4-FFF2-40B4-BE49-F238E27FC236}">
-                <a16:creationId xmlns:a16="http://schemas.microsoft.com/office/drawing/2014/main" id="{6024BB38-B78F-484D-83B8-DDCE9895D83A}"/>
+                <a16:creationId xmlns:a16="http://schemas.microsoft.com/office/drawing/2014/main" id="{CAC589D1-EA70-4AC0-A8FA-7F34565B81F5}"/>
               </a:ext>
             </a:extLst>
           </p:cNvPr>
@@ -3852,7 +3727,7 @@
           <p:cNvPr id="6" name="">
             <a:extLst xmlns:a="http://schemas.openxmlformats.org/drawingml/2006/main">
               <a:ext uri="{FF2B5EF4-FFF2-40B4-BE49-F238E27FC236}">
-                <a16:creationId xmlns:a16="http://schemas.microsoft.com/office/drawing/2014/main" id="{AB0D85BC-E900-46CB-BAE1-C07807971FBD}"/>
+                <a16:creationId xmlns:a16="http://schemas.microsoft.com/office/drawing/2014/main" id="{D4837D4A-35DD-40D2-AE15-B6155CEA1A6D}"/>
               </a:ext>
             </a:extLst>
           </p:cNvPr>
@@ -3908,7 +3783,7 @@
           <p:cNvPr id="7" name="">
             <a:extLst xmlns:a="http://schemas.openxmlformats.org/drawingml/2006/main">
               <a:ext uri="{FF2B5EF4-FFF2-40B4-BE49-F238E27FC236}">
-                <a16:creationId xmlns:a16="http://schemas.microsoft.com/office/drawing/2014/main" id="{913AD3F0-CBA0-47B0-828E-8181664071FD}"/>
+                <a16:creationId xmlns:a16="http://schemas.microsoft.com/office/drawing/2014/main" id="{AC489A9E-CEAF-4850-9BDE-DEFFB0A8332F}"/>
               </a:ext>
             </a:extLst>
           </p:cNvPr>
@@ -3964,7 +3839,7 @@
           <p:cNvPr id="8" name="">
             <a:extLst xmlns:a="http://schemas.openxmlformats.org/drawingml/2006/main">
               <a:ext uri="{FF2B5EF4-FFF2-40B4-BE49-F238E27FC236}">
-                <a16:creationId xmlns:a16="http://schemas.microsoft.com/office/drawing/2014/main" id="{D3AE2EC7-874C-4160-864D-CD9242890FCB}"/>
+                <a16:creationId xmlns:a16="http://schemas.microsoft.com/office/drawing/2014/main" id="{11A02BD8-C5B0-4D9C-AF5D-7EEFBA6BBD84}"/>
               </a:ext>
             </a:extLst>
           </p:cNvPr>
@@ -4020,7 +3895,7 @@
           <p:cNvPr id="9" name="">
             <a:extLst xmlns:a="http://schemas.openxmlformats.org/drawingml/2006/main">
               <a:ext uri="{FF2B5EF4-FFF2-40B4-BE49-F238E27FC236}">
-                <a16:creationId xmlns:a16="http://schemas.microsoft.com/office/drawing/2014/main" id="{F5E3878A-F6EE-4374-B28C-1DA2B1ECEFC1}"/>
+                <a16:creationId xmlns:a16="http://schemas.microsoft.com/office/drawing/2014/main" id="{4CB563DA-36FC-4C6E-8D5F-EDE0D60CA9B0}"/>
               </a:ext>
             </a:extLst>
           </p:cNvPr>
@@ -4076,7 +3951,7 @@
           <p:cNvPr id="10" name="">
             <a:extLst xmlns:a="http://schemas.openxmlformats.org/drawingml/2006/main">
               <a:ext uri="{FF2B5EF4-FFF2-40B4-BE49-F238E27FC236}">
-                <a16:creationId xmlns:a16="http://schemas.microsoft.com/office/drawing/2014/main" id="{926ACF50-263C-4826-BA69-A389E0BCD2EA}"/>
+                <a16:creationId xmlns:a16="http://schemas.microsoft.com/office/drawing/2014/main" id="{012DAF4D-165B-4594-AB97-6444E15219E5}"/>
               </a:ext>
             </a:extLst>
           </p:cNvPr>
@@ -4132,7 +4007,7 @@
           <p:cNvPr id="11" name="">
             <a:extLst xmlns:a="http://schemas.openxmlformats.org/drawingml/2006/main">
               <a:ext uri="{FF2B5EF4-FFF2-40B4-BE49-F238E27FC236}">
-                <a16:creationId xmlns:a16="http://schemas.microsoft.com/office/drawing/2014/main" id="{86B1136A-5DDD-4102-9C3E-9C3B62FBEAA4}"/>
+                <a16:creationId xmlns:a16="http://schemas.microsoft.com/office/drawing/2014/main" id="{77CE0D80-7CC8-4CDA-8ACC-424AC9F0D01C}"/>
               </a:ext>
             </a:extLst>
           </p:cNvPr>
@@ -4188,7 +4063,7 @@
           <p:cNvPr id="12" name="">
             <a:extLst xmlns:a="http://schemas.openxmlformats.org/drawingml/2006/main">
               <a:ext uri="{FF2B5EF4-FFF2-40B4-BE49-F238E27FC236}">
-                <a16:creationId xmlns:a16="http://schemas.microsoft.com/office/drawing/2014/main" id="{F1DD3C70-63E8-4C57-9F6E-E1C90387D64E}"/>
+                <a16:creationId xmlns:a16="http://schemas.microsoft.com/office/drawing/2014/main" id="{C286FCD7-D76F-4488-B516-2567127D76CA}"/>
               </a:ext>
             </a:extLst>
           </p:cNvPr>
@@ -4244,7 +4119,7 @@
           <p:cNvPr id="13" name="">
             <a:extLst xmlns:a="http://schemas.openxmlformats.org/drawingml/2006/main">
               <a:ext uri="{FF2B5EF4-FFF2-40B4-BE49-F238E27FC236}">
-                <a16:creationId xmlns:a16="http://schemas.microsoft.com/office/drawing/2014/main" id="{54F4A5DF-9004-46F1-A4C6-E68B75EB94DF}"/>
+                <a16:creationId xmlns:a16="http://schemas.microsoft.com/office/drawing/2014/main" id="{A377C703-E130-4428-8028-2080340DFBB0}"/>
               </a:ext>
             </a:extLst>
           </p:cNvPr>
@@ -4300,7 +4175,7 @@
           <p:cNvPr id="14" name="">
             <a:extLst xmlns:a="http://schemas.openxmlformats.org/drawingml/2006/main">
               <a:ext uri="{FF2B5EF4-FFF2-40B4-BE49-F238E27FC236}">
-                <a16:creationId xmlns:a16="http://schemas.microsoft.com/office/drawing/2014/main" id="{1FC3B9F8-7178-460D-AAA0-813FEB31FE7E}"/>
+                <a16:creationId xmlns:a16="http://schemas.microsoft.com/office/drawing/2014/main" id="{2789CDD9-1547-4314-956E-EDEC28C74934}"/>
               </a:ext>
             </a:extLst>
           </p:cNvPr>
@@ -4360,7 +4235,7 @@
           <p:cNvPr id="15" name="">
             <a:extLst xmlns:a="http://schemas.openxmlformats.org/drawingml/2006/main">
               <a:ext uri="{FF2B5EF4-FFF2-40B4-BE49-F238E27FC236}">
-                <a16:creationId xmlns:a16="http://schemas.microsoft.com/office/drawing/2014/main" id="{C2E98C9D-1B7C-42E9-A062-DBBD6C5B5BFD}"/>
+                <a16:creationId xmlns:a16="http://schemas.microsoft.com/office/drawing/2014/main" id="{F4CCEA98-5F62-4D6F-8229-9437B32B363D}"/>
               </a:ext>
             </a:extLst>
           </p:cNvPr>
@@ -4391,7 +4266,7 @@
           <p:cNvPr id="16" name="source-footer">
             <a:extLst xmlns:a="http://schemas.openxmlformats.org/drawingml/2006/main">
               <a:ext uri="{FF2B5EF4-FFF2-40B4-BE49-F238E27FC236}">
-                <a16:creationId xmlns:a16="http://schemas.microsoft.com/office/drawing/2014/main" id="{CF3E77C8-B964-43D2-AF4D-A8B3FCEB393D}"/>
+                <a16:creationId xmlns:a16="http://schemas.microsoft.com/office/drawing/2014/main" id="{F43C9679-665E-41D2-9404-CE399F0E7A13}"/>
               </a:ext>
             </a:extLst>
           </p:cNvPr>
@@ -4447,7 +4322,7 @@
           <p:cNvPr id="17" name="slide-number">
             <a:extLst xmlns:a="http://schemas.openxmlformats.org/drawingml/2006/main">
               <a:ext uri="{FF2B5EF4-FFF2-40B4-BE49-F238E27FC236}">
-                <a16:creationId xmlns:a16="http://schemas.microsoft.com/office/drawing/2014/main" id="{0F718D76-E8F7-474D-8F60-67F5B951DF66}"/>
+                <a16:creationId xmlns:a16="http://schemas.microsoft.com/office/drawing/2014/main" id="{D05D8CF6-E99D-41D8-B34A-6BC2CE10BBFE}"/>
               </a:ext>
             </a:extLst>
           </p:cNvPr>
@@ -4501,7 +4376,7 @@
     </p:spTree>
     <p:extLst>
       <p:ext uri="{BB962C8B-B14F-4D97-AF65-F5344CB8AC3E}">
-        <p14:creationId xmlns:p14="http://schemas.microsoft.com/office/powerpoint/2010/main" val="1259541429"/>
+        <p14:creationId xmlns:p14="http://schemas.microsoft.com/office/powerpoint/2010/main" val="1242373490"/>
       </p:ext>
     </p:extLst>
   </p:cSld>
@@ -4532,7 +4407,7 @@
           <p:cNvPr id="10" name="slide-title">
             <a:extLst xmlns:a="http://schemas.openxmlformats.org/drawingml/2006/main">
               <a:ext uri="{FF2B5EF4-FFF2-40B4-BE49-F238E27FC236}">
-                <a16:creationId xmlns:a16="http://schemas.microsoft.com/office/drawing/2014/main" id="{147DDB4D-EA7C-4C4E-97D0-E3B7DAD96462}"/>
+                <a16:creationId xmlns:a16="http://schemas.microsoft.com/office/drawing/2014/main" id="{62B449EC-A521-4A57-993E-7AF473C53B1E}"/>
               </a:ext>
             </a:extLst>
           </p:cNvPr>
@@ -4588,7 +4463,7 @@
           <p:cNvPr id="2" name="backup-label">
             <a:extLst xmlns:a="http://schemas.openxmlformats.org/drawingml/2006/main">
               <a:ext uri="{FF2B5EF4-FFF2-40B4-BE49-F238E27FC236}">
-                <a16:creationId xmlns:a16="http://schemas.microsoft.com/office/drawing/2014/main" id="{07E98F2E-DCDE-44D6-AD63-51FC9B055C00}"/>
+                <a16:creationId xmlns:a16="http://schemas.microsoft.com/office/drawing/2014/main" id="{0C848408-5A2E-4C7A-A5AA-DD5A4B04E086}"/>
               </a:ext>
             </a:extLst>
           </p:cNvPr>
@@ -4648,7 +4523,7 @@
           <p:cNvPr id="3" name="">
             <a:extLst xmlns:a="http://schemas.openxmlformats.org/drawingml/2006/main">
               <a:ext uri="{FF2B5EF4-FFF2-40B4-BE49-F238E27FC236}">
-                <a16:creationId xmlns:a16="http://schemas.microsoft.com/office/drawing/2014/main" id="{D201FF18-9E9C-4976-872C-E3FFCD37660C}"/>
+                <a16:creationId xmlns:a16="http://schemas.microsoft.com/office/drawing/2014/main" id="{D353D681-9F68-4921-B646-59593C49EFDB}"/>
               </a:ext>
             </a:extLst>
           </p:cNvPr>
@@ -5117,7 +4992,7 @@
           <p:cNvPr id="5" name="">
             <a:extLst xmlns:a="http://schemas.openxmlformats.org/drawingml/2006/main">
               <a:ext uri="{FF2B5EF4-FFF2-40B4-BE49-F238E27FC236}">
-                <a16:creationId xmlns:a16="http://schemas.microsoft.com/office/drawing/2014/main" id="{87D8CB37-2E1C-43DF-9286-0DF598351925}"/>
+                <a16:creationId xmlns:a16="http://schemas.microsoft.com/office/drawing/2014/main" id="{43B6C405-8318-433B-81B2-D78A2F4E1DE7}"/>
               </a:ext>
             </a:extLst>
           </p:cNvPr>
@@ -5177,7 +5052,7 @@
           <p:cNvPr id="6" name="">
             <a:extLst xmlns:a="http://schemas.openxmlformats.org/drawingml/2006/main">
               <a:ext uri="{FF2B5EF4-FFF2-40B4-BE49-F238E27FC236}">
-                <a16:creationId xmlns:a16="http://schemas.microsoft.com/office/drawing/2014/main" id="{99A6C732-23E9-4F38-B140-695FF2333CBF}"/>
+                <a16:creationId xmlns:a16="http://schemas.microsoft.com/office/drawing/2014/main" id="{DAD934B2-885A-4DC8-ADEA-47DB96DCD1E3}"/>
               </a:ext>
             </a:extLst>
           </p:cNvPr>
@@ -5233,7 +5108,7 @@
           <p:cNvPr id="7" name="">
             <a:extLst xmlns:a="http://schemas.openxmlformats.org/drawingml/2006/main">
               <a:ext uri="{FF2B5EF4-FFF2-40B4-BE49-F238E27FC236}">
-                <a16:creationId xmlns:a16="http://schemas.microsoft.com/office/drawing/2014/main" id="{429BB9EF-7DBF-4B10-B8D7-45BBB4CB7DD8}"/>
+                <a16:creationId xmlns:a16="http://schemas.microsoft.com/office/drawing/2014/main" id="{B7F4296F-C72D-4846-BF07-4E364126ED65}"/>
               </a:ext>
             </a:extLst>
           </p:cNvPr>
@@ -5264,7 +5139,7 @@
           <p:cNvPr id="8" name="source-footer">
             <a:extLst xmlns:a="http://schemas.openxmlformats.org/drawingml/2006/main">
               <a:ext uri="{FF2B5EF4-FFF2-40B4-BE49-F238E27FC236}">
-                <a16:creationId xmlns:a16="http://schemas.microsoft.com/office/drawing/2014/main" id="{8BE29686-F249-460C-95EC-1936651DDD22}"/>
+                <a16:creationId xmlns:a16="http://schemas.microsoft.com/office/drawing/2014/main" id="{5A5503EC-3D14-4601-89DB-6B55D3BAFE03}"/>
               </a:ext>
             </a:extLst>
           </p:cNvPr>
@@ -5320,7 +5195,7 @@
           <p:cNvPr id="9" name="slide-number">
             <a:extLst xmlns:a="http://schemas.openxmlformats.org/drawingml/2006/main">
               <a:ext uri="{FF2B5EF4-FFF2-40B4-BE49-F238E27FC236}">
-                <a16:creationId xmlns:a16="http://schemas.microsoft.com/office/drawing/2014/main" id="{909C979C-AF80-4B8F-963B-1B86B369EBE1}"/>
+                <a16:creationId xmlns:a16="http://schemas.microsoft.com/office/drawing/2014/main" id="{B51AF8DF-C83F-4862-85A2-9CB4FF30C1C6}"/>
               </a:ext>
             </a:extLst>
           </p:cNvPr>
@@ -5374,7 +5249,7 @@
     </p:spTree>
     <p:extLst>
       <p:ext uri="{BB962C8B-B14F-4D97-AF65-F5344CB8AC3E}">
-        <p14:creationId xmlns:p14="http://schemas.microsoft.com/office/powerpoint/2010/main" val="855900773"/>
+        <p14:creationId xmlns:p14="http://schemas.microsoft.com/office/powerpoint/2010/main" val="215979258"/>
       </p:ext>
     </p:extLst>
   </p:cSld>
@@ -5405,7 +5280,7 @@
           <p:cNvPr id="23" name="slide-title">
             <a:extLst xmlns:a="http://schemas.openxmlformats.org/drawingml/2006/main">
               <a:ext uri="{FF2B5EF4-FFF2-40B4-BE49-F238E27FC236}">
-                <a16:creationId xmlns:a16="http://schemas.microsoft.com/office/drawing/2014/main" id="{37892540-DC72-4738-A4D6-3801CBCD08AC}"/>
+                <a16:creationId xmlns:a16="http://schemas.microsoft.com/office/drawing/2014/main" id="{8FB3EA6E-C356-4F8E-8EE0-EE2CC1A2C954}"/>
               </a:ext>
             </a:extLst>
           </p:cNvPr>
@@ -5461,7 +5336,7 @@
           <p:cNvPr id="2" name="backup-label">
             <a:extLst xmlns:a="http://schemas.openxmlformats.org/drawingml/2006/main">
               <a:ext uri="{FF2B5EF4-FFF2-40B4-BE49-F238E27FC236}">
-                <a16:creationId xmlns:a16="http://schemas.microsoft.com/office/drawing/2014/main" id="{36759F26-38EF-4A8B-A5A0-6BEDAB9B393F}"/>
+                <a16:creationId xmlns:a16="http://schemas.microsoft.com/office/drawing/2014/main" id="{D3645542-2510-4449-9A4B-D5DAD37761FF}"/>
               </a:ext>
             </a:extLst>
           </p:cNvPr>
@@ -5521,7 +5396,7 @@
           <p:cNvPr id="3" name="">
             <a:extLst xmlns:a="http://schemas.openxmlformats.org/drawingml/2006/main">
               <a:ext uri="{FF2B5EF4-FFF2-40B4-BE49-F238E27FC236}">
-                <a16:creationId xmlns:a16="http://schemas.microsoft.com/office/drawing/2014/main" id="{8B3F600F-FE58-4041-A6ED-A9EF5CC12E70}"/>
+                <a16:creationId xmlns:a16="http://schemas.microsoft.com/office/drawing/2014/main" id="{949C80B2-9083-471B-ADB5-20EDA903BB0F}"/>
               </a:ext>
             </a:extLst>
           </p:cNvPr>
@@ -5552,7 +5427,7 @@
           <p:cNvPr id="4" name="shared-model">
             <a:extLst xmlns:a="http://schemas.openxmlformats.org/drawingml/2006/main">
               <a:ext uri="{FF2B5EF4-FFF2-40B4-BE49-F238E27FC236}">
-                <a16:creationId xmlns:a16="http://schemas.microsoft.com/office/drawing/2014/main" id="{2B533C94-01BA-4A19-A6DC-9794BC90FC14}"/>
+                <a16:creationId xmlns:a16="http://schemas.microsoft.com/office/drawing/2014/main" id="{86345F3A-F80B-4549-842E-3F9AA8634862}"/>
               </a:ext>
             </a:extLst>
           </p:cNvPr>
@@ -5585,7 +5460,7 @@
           <p:cNvPr id="5" name="">
             <a:extLst xmlns:a="http://schemas.openxmlformats.org/drawingml/2006/main">
               <a:ext uri="{FF2B5EF4-FFF2-40B4-BE49-F238E27FC236}">
-                <a16:creationId xmlns:a16="http://schemas.microsoft.com/office/drawing/2014/main" id="{973582C4-8097-4EB7-8792-6FAFEE0E02C2}"/>
+                <a16:creationId xmlns:a16="http://schemas.microsoft.com/office/drawing/2014/main" id="{E3A25C09-98AE-4F30-B817-4DC9BA560B1E}"/>
               </a:ext>
             </a:extLst>
           </p:cNvPr>
@@ -5641,7 +5516,7 @@
           <p:cNvPr id="6" name="">
             <a:extLst xmlns:a="http://schemas.openxmlformats.org/drawingml/2006/main">
               <a:ext uri="{FF2B5EF4-FFF2-40B4-BE49-F238E27FC236}">
-                <a16:creationId xmlns:a16="http://schemas.microsoft.com/office/drawing/2014/main" id="{B5F0364D-E767-42B4-B4DA-19B4A008BD01}"/>
+                <a16:creationId xmlns:a16="http://schemas.microsoft.com/office/drawing/2014/main" id="{001AEF22-1F58-4F40-8E5A-7482F6AB478B}"/>
               </a:ext>
             </a:extLst>
           </p:cNvPr>
@@ -5697,7 +5572,7 @@
           <p:cNvPr id="7" name="implementation-Q2">
             <a:extLst xmlns:a="http://schemas.openxmlformats.org/drawingml/2006/main">
               <a:ext uri="{FF2B5EF4-FFF2-40B4-BE49-F238E27FC236}">
-                <a16:creationId xmlns:a16="http://schemas.microsoft.com/office/drawing/2014/main" id="{C4167231-D104-4DDA-B79A-260F52DC7601}"/>
+                <a16:creationId xmlns:a16="http://schemas.microsoft.com/office/drawing/2014/main" id="{C6D3A1ED-78D2-45BA-83C2-8B8A3669B688}"/>
               </a:ext>
             </a:extLst>
           </p:cNvPr>
@@ -5732,7 +5607,7 @@
           <p:cNvPr id="8" name="">
             <a:extLst xmlns:a="http://schemas.openxmlformats.org/drawingml/2006/main">
               <a:ext uri="{FF2B5EF4-FFF2-40B4-BE49-F238E27FC236}">
-                <a16:creationId xmlns:a16="http://schemas.microsoft.com/office/drawing/2014/main" id="{5C50083A-CC9A-4ADE-9DB1-21429A9A3751}"/>
+                <a16:creationId xmlns:a16="http://schemas.microsoft.com/office/drawing/2014/main" id="{83955093-DA0C-439C-82C8-CEE36C2CC878}"/>
               </a:ext>
             </a:extLst>
           </p:cNvPr>
@@ -5788,7 +5663,7 @@
           <p:cNvPr id="9" name="">
             <a:extLst xmlns:a="http://schemas.openxmlformats.org/drawingml/2006/main">
               <a:ext uri="{FF2B5EF4-FFF2-40B4-BE49-F238E27FC236}">
-                <a16:creationId xmlns:a16="http://schemas.microsoft.com/office/drawing/2014/main" id="{25C4B00D-A974-4961-BE0F-7FD303C1FFD8}"/>
+                <a16:creationId xmlns:a16="http://schemas.microsoft.com/office/drawing/2014/main" id="{331D179A-A643-46A8-88D4-F1B04788DC7E}"/>
               </a:ext>
             </a:extLst>
           </p:cNvPr>
@@ -5844,7 +5719,7 @@
           <p:cNvPr id="10" name="implementation-Q3">
             <a:extLst xmlns:a="http://schemas.openxmlformats.org/drawingml/2006/main">
               <a:ext uri="{FF2B5EF4-FFF2-40B4-BE49-F238E27FC236}">
-                <a16:creationId xmlns:a16="http://schemas.microsoft.com/office/drawing/2014/main" id="{6E45231B-D576-4DCD-B7B4-813C2C9D9433}"/>
+                <a16:creationId xmlns:a16="http://schemas.microsoft.com/office/drawing/2014/main" id="{3D9FBE00-30D5-45B2-B92D-A6DFD037F3DD}"/>
               </a:ext>
             </a:extLst>
           </p:cNvPr>
@@ -5879,7 +5754,7 @@
           <p:cNvPr id="11" name="">
             <a:extLst xmlns:a="http://schemas.openxmlformats.org/drawingml/2006/main">
               <a:ext uri="{FF2B5EF4-FFF2-40B4-BE49-F238E27FC236}">
-                <a16:creationId xmlns:a16="http://schemas.microsoft.com/office/drawing/2014/main" id="{7725BE18-4DB5-4761-8ED2-516A170A03C1}"/>
+                <a16:creationId xmlns:a16="http://schemas.microsoft.com/office/drawing/2014/main" id="{7912FEB0-6DA3-49DA-9394-ACC6281BD1C0}"/>
               </a:ext>
             </a:extLst>
           </p:cNvPr>
@@ -5935,7 +5810,7 @@
           <p:cNvPr id="12" name="">
             <a:extLst xmlns:a="http://schemas.openxmlformats.org/drawingml/2006/main">
               <a:ext uri="{FF2B5EF4-FFF2-40B4-BE49-F238E27FC236}">
-                <a16:creationId xmlns:a16="http://schemas.microsoft.com/office/drawing/2014/main" id="{0328ADF8-99BC-4ACD-A29E-993CAF7FD671}"/>
+                <a16:creationId xmlns:a16="http://schemas.microsoft.com/office/drawing/2014/main" id="{E033CF09-0C42-46A9-BDB2-E0A906C4794F}"/>
               </a:ext>
             </a:extLst>
           </p:cNvPr>
@@ -5991,7 +5866,7 @@
           <p:cNvPr id="13" name="implementation-Q4">
             <a:extLst xmlns:a="http://schemas.openxmlformats.org/drawingml/2006/main">
               <a:ext uri="{FF2B5EF4-FFF2-40B4-BE49-F238E27FC236}">
-                <a16:creationId xmlns:a16="http://schemas.microsoft.com/office/drawing/2014/main" id="{CBC2A269-8FB5-4F8B-9AA4-F461D096D8D9}"/>
+                <a16:creationId xmlns:a16="http://schemas.microsoft.com/office/drawing/2014/main" id="{4B9C1EA8-64C5-4D59-88BC-B68A76F1B495}"/>
               </a:ext>
             </a:extLst>
           </p:cNvPr>
@@ -6026,7 +5901,7 @@
           <p:cNvPr id="14" name="">
             <a:extLst xmlns:a="http://schemas.openxmlformats.org/drawingml/2006/main">
               <a:ext uri="{FF2B5EF4-FFF2-40B4-BE49-F238E27FC236}">
-                <a16:creationId xmlns:a16="http://schemas.microsoft.com/office/drawing/2014/main" id="{F89B8E53-9749-4B38-8AF8-8CEE4219161D}"/>
+                <a16:creationId xmlns:a16="http://schemas.microsoft.com/office/drawing/2014/main" id="{9DC5C578-72C2-4920-84ED-D7544154D6E3}"/>
               </a:ext>
             </a:extLst>
           </p:cNvPr>
@@ -6082,7 +5957,7 @@
           <p:cNvPr id="15" name="">
             <a:extLst xmlns:a="http://schemas.openxmlformats.org/drawingml/2006/main">
               <a:ext uri="{FF2B5EF4-FFF2-40B4-BE49-F238E27FC236}">
-                <a16:creationId xmlns:a16="http://schemas.microsoft.com/office/drawing/2014/main" id="{497F7BC6-665D-4134-B38B-8DF9B98A0E15}"/>
+                <a16:creationId xmlns:a16="http://schemas.microsoft.com/office/drawing/2014/main" id="{3AD0B2D3-2C5C-4B6F-8881-688B497BB187}"/>
               </a:ext>
             </a:extLst>
           </p:cNvPr>
@@ -6225,7 +6100,7 @@
           <p:cNvPr id="19" name="">
             <a:extLst xmlns:a="http://schemas.openxmlformats.org/drawingml/2006/main">
               <a:ext uri="{FF2B5EF4-FFF2-40B4-BE49-F238E27FC236}">
-                <a16:creationId xmlns:a16="http://schemas.microsoft.com/office/drawing/2014/main" id="{2DB31AFA-DB6F-45BA-B756-485C356F6BD3}"/>
+                <a16:creationId xmlns:a16="http://schemas.microsoft.com/office/drawing/2014/main" id="{31BD16DA-66F2-451C-A9F8-7FB578DEEAF1}"/>
               </a:ext>
             </a:extLst>
           </p:cNvPr>
@@ -6281,7 +6156,7 @@
           <p:cNvPr id="20" name="">
             <a:extLst xmlns:a="http://schemas.openxmlformats.org/drawingml/2006/main">
               <a:ext uri="{FF2B5EF4-FFF2-40B4-BE49-F238E27FC236}">
-                <a16:creationId xmlns:a16="http://schemas.microsoft.com/office/drawing/2014/main" id="{E360A9FA-089A-4D82-9375-24791A7B52B6}"/>
+                <a16:creationId xmlns:a16="http://schemas.microsoft.com/office/drawing/2014/main" id="{D731739D-6432-440F-B1A3-642D3D786BC0}"/>
               </a:ext>
             </a:extLst>
           </p:cNvPr>
@@ -6312,7 +6187,7 @@
           <p:cNvPr id="21" name="source-footer">
             <a:extLst xmlns:a="http://schemas.openxmlformats.org/drawingml/2006/main">
               <a:ext uri="{FF2B5EF4-FFF2-40B4-BE49-F238E27FC236}">
-                <a16:creationId xmlns:a16="http://schemas.microsoft.com/office/drawing/2014/main" id="{30DFF278-2C7A-4AAE-9CAF-6A85D2EC2BE9}"/>
+                <a16:creationId xmlns:a16="http://schemas.microsoft.com/office/drawing/2014/main" id="{01463ADD-91DB-4076-87AE-461FA2E42BDF}"/>
               </a:ext>
             </a:extLst>
           </p:cNvPr>
@@ -6368,7 +6243,7 @@
           <p:cNvPr id="22" name="slide-number">
             <a:extLst xmlns:a="http://schemas.openxmlformats.org/drawingml/2006/main">
               <a:ext uri="{FF2B5EF4-FFF2-40B4-BE49-F238E27FC236}">
-                <a16:creationId xmlns:a16="http://schemas.microsoft.com/office/drawing/2014/main" id="{A6615770-04E0-4653-835B-79D48EFD059B}"/>
+                <a16:creationId xmlns:a16="http://schemas.microsoft.com/office/drawing/2014/main" id="{8654AF13-3FF1-4E19-86F0-8A4190000471}"/>
               </a:ext>
             </a:extLst>
           </p:cNvPr>
@@ -6422,7 +6297,7 @@
     </p:spTree>
     <p:extLst>
       <p:ext uri="{BB962C8B-B14F-4D97-AF65-F5344CB8AC3E}">
-        <p14:creationId xmlns:p14="http://schemas.microsoft.com/office/powerpoint/2010/main" val="924164509"/>
+        <p14:creationId xmlns:p14="http://schemas.microsoft.com/office/powerpoint/2010/main" val="988951543"/>
       </p:ext>
     </p:extLst>
   </p:cSld>
@@ -6453,7 +6328,7 @@
           <p:cNvPr id="18" name="slide-title">
             <a:extLst xmlns:a="http://schemas.openxmlformats.org/drawingml/2006/main">
               <a:ext uri="{FF2B5EF4-FFF2-40B4-BE49-F238E27FC236}">
-                <a16:creationId xmlns:a16="http://schemas.microsoft.com/office/drawing/2014/main" id="{DF04BB65-B007-415D-B99B-C55E9EC3FB13}"/>
+                <a16:creationId xmlns:a16="http://schemas.microsoft.com/office/drawing/2014/main" id="{D1A5BB5A-D087-484E-8618-92C9E7A9BEF6}"/>
               </a:ext>
             </a:extLst>
           </p:cNvPr>
@@ -6509,7 +6384,7 @@
           <p:cNvPr id="2" name="backup-label">
             <a:extLst xmlns:a="http://schemas.openxmlformats.org/drawingml/2006/main">
               <a:ext uri="{FF2B5EF4-FFF2-40B4-BE49-F238E27FC236}">
-                <a16:creationId xmlns:a16="http://schemas.microsoft.com/office/drawing/2014/main" id="{4814B3A0-90D9-40BF-B29E-4BE864FC783E}"/>
+                <a16:creationId xmlns:a16="http://schemas.microsoft.com/office/drawing/2014/main" id="{367BD4E3-4C8F-49EB-A32C-224125867001}"/>
               </a:ext>
             </a:extLst>
           </p:cNvPr>
@@ -6569,7 +6444,7 @@
           <p:cNvPr id="3" name="">
             <a:extLst xmlns:a="http://schemas.openxmlformats.org/drawingml/2006/main">
               <a:ext uri="{FF2B5EF4-FFF2-40B4-BE49-F238E27FC236}">
-                <a16:creationId xmlns:a16="http://schemas.microsoft.com/office/drawing/2014/main" id="{E3E7DC7A-5DF5-4530-938A-41C55D220EDD}"/>
+                <a16:creationId xmlns:a16="http://schemas.microsoft.com/office/drawing/2014/main" id="{49B35C4A-6DE0-424F-98C3-ACC4EE5EF497}"/>
               </a:ext>
             </a:extLst>
           </p:cNvPr>
@@ -6600,7 +6475,7 @@
           <p:cNvPr id="4" name="">
             <a:extLst xmlns:a="http://schemas.openxmlformats.org/drawingml/2006/main">
               <a:ext uri="{FF2B5EF4-FFF2-40B4-BE49-F238E27FC236}">
-                <a16:creationId xmlns:a16="http://schemas.microsoft.com/office/drawing/2014/main" id="{5E3FB0F4-AC92-4B11-87CF-0C7FE107C55D}"/>
+                <a16:creationId xmlns:a16="http://schemas.microsoft.com/office/drawing/2014/main" id="{65B23FD5-F2AE-4E24-97D0-E6A040604D5B}"/>
               </a:ext>
             </a:extLst>
           </p:cNvPr>
@@ -6656,7 +6531,7 @@
           <p:cNvPr id="5" name="">
             <a:extLst xmlns:a="http://schemas.openxmlformats.org/drawingml/2006/main">
               <a:ext uri="{FF2B5EF4-FFF2-40B4-BE49-F238E27FC236}">
-                <a16:creationId xmlns:a16="http://schemas.microsoft.com/office/drawing/2014/main" id="{9362E532-9B82-4670-A935-B236FAF02ADC}"/>
+                <a16:creationId xmlns:a16="http://schemas.microsoft.com/office/drawing/2014/main" id="{533ECC94-657F-470D-B8F2-5644FF485934}"/>
               </a:ext>
             </a:extLst>
           </p:cNvPr>
@@ -6687,7 +6562,7 @@
           <p:cNvPr id="6" name="">
             <a:extLst xmlns:a="http://schemas.openxmlformats.org/drawingml/2006/main">
               <a:ext uri="{FF2B5EF4-FFF2-40B4-BE49-F238E27FC236}">
-                <a16:creationId xmlns:a16="http://schemas.microsoft.com/office/drawing/2014/main" id="{BA22A576-9E5C-4127-A571-10E4059D2C66}"/>
+                <a16:creationId xmlns:a16="http://schemas.microsoft.com/office/drawing/2014/main" id="{7D84FBA0-D7A6-4029-A6A7-11292A2510B8}"/>
               </a:ext>
             </a:extLst>
           </p:cNvPr>
@@ -6743,7 +6618,7 @@
           <p:cNvPr id="7" name="">
             <a:extLst xmlns:a="http://schemas.openxmlformats.org/drawingml/2006/main">
               <a:ext uri="{FF2B5EF4-FFF2-40B4-BE49-F238E27FC236}">
-                <a16:creationId xmlns:a16="http://schemas.microsoft.com/office/drawing/2014/main" id="{1D6F3729-6EEA-4BA0-867B-E38247CE459A}"/>
+                <a16:creationId xmlns:a16="http://schemas.microsoft.com/office/drawing/2014/main" id="{BA9CE17B-6203-47BF-BFE2-FED8F2315A40}"/>
               </a:ext>
             </a:extLst>
           </p:cNvPr>
@@ -6774,7 +6649,7 @@
           <p:cNvPr id="8" name="">
             <a:extLst xmlns:a="http://schemas.openxmlformats.org/drawingml/2006/main">
               <a:ext uri="{FF2B5EF4-FFF2-40B4-BE49-F238E27FC236}">
-                <a16:creationId xmlns:a16="http://schemas.microsoft.com/office/drawing/2014/main" id="{1E1DED4D-6EAF-4CB9-8EEB-D4E3DB24C2C8}"/>
+                <a16:creationId xmlns:a16="http://schemas.microsoft.com/office/drawing/2014/main" id="{EED4A5B7-C640-4FC0-A95B-5896DA00BE1A}"/>
               </a:ext>
             </a:extLst>
           </p:cNvPr>
@@ -6830,7 +6705,7 @@
           <p:cNvPr id="9" name="">
             <a:extLst xmlns:a="http://schemas.openxmlformats.org/drawingml/2006/main">
               <a:ext uri="{FF2B5EF4-FFF2-40B4-BE49-F238E27FC236}">
-                <a16:creationId xmlns:a16="http://schemas.microsoft.com/office/drawing/2014/main" id="{CB1368BC-E8C2-4399-84FB-823E25FA1E08}"/>
+                <a16:creationId xmlns:a16="http://schemas.microsoft.com/office/drawing/2014/main" id="{3BC0184E-34AB-444B-B124-85B97FC8389E}"/>
               </a:ext>
             </a:extLst>
           </p:cNvPr>
@@ -6861,7 +6736,7 @@
           <p:cNvPr id="10" name="">
             <a:extLst xmlns:a="http://schemas.openxmlformats.org/drawingml/2006/main">
               <a:ext uri="{FF2B5EF4-FFF2-40B4-BE49-F238E27FC236}">
-                <a16:creationId xmlns:a16="http://schemas.microsoft.com/office/drawing/2014/main" id="{A277B1C5-A548-4410-80E2-C8FB4888E851}"/>
+                <a16:creationId xmlns:a16="http://schemas.microsoft.com/office/drawing/2014/main" id="{B67CE072-F5FF-47ED-9BBE-EE93A9DAB4A0}"/>
               </a:ext>
             </a:extLst>
           </p:cNvPr>
@@ -6917,7 +6792,7 @@
           <p:cNvPr id="11" name="">
             <a:extLst xmlns:a="http://schemas.openxmlformats.org/drawingml/2006/main">
               <a:ext uri="{FF2B5EF4-FFF2-40B4-BE49-F238E27FC236}">
-                <a16:creationId xmlns:a16="http://schemas.microsoft.com/office/drawing/2014/main" id="{4E47A32C-E700-4575-8089-6D4B84433780}"/>
+                <a16:creationId xmlns:a16="http://schemas.microsoft.com/office/drawing/2014/main" id="{C6AF4750-D9F7-4324-8659-2C080B8CCDE8}"/>
               </a:ext>
             </a:extLst>
           </p:cNvPr>
@@ -6950,7 +6825,7 @@
           <p:cNvPr id="12" name="">
             <a:extLst xmlns:a="http://schemas.openxmlformats.org/drawingml/2006/main">
               <a:ext uri="{FF2B5EF4-FFF2-40B4-BE49-F238E27FC236}">
-                <a16:creationId xmlns:a16="http://schemas.microsoft.com/office/drawing/2014/main" id="{844CB682-4C8F-4437-A614-E872E24EB897}"/>
+                <a16:creationId xmlns:a16="http://schemas.microsoft.com/office/drawing/2014/main" id="{F624DA29-72BF-41C8-A60D-C21315E0F4A1}"/>
               </a:ext>
             </a:extLst>
           </p:cNvPr>
@@ -7006,7 +6881,7 @@
           <p:cNvPr id="13" name="">
             <a:extLst xmlns:a="http://schemas.openxmlformats.org/drawingml/2006/main">
               <a:ext uri="{FF2B5EF4-FFF2-40B4-BE49-F238E27FC236}">
-                <a16:creationId xmlns:a16="http://schemas.microsoft.com/office/drawing/2014/main" id="{C1FB17D3-4AE3-4538-B084-B618BAD34417}"/>
+                <a16:creationId xmlns:a16="http://schemas.microsoft.com/office/drawing/2014/main" id="{F8C2E63B-185B-4D45-987E-580074EBCFEE}"/>
               </a:ext>
             </a:extLst>
           </p:cNvPr>
@@ -7062,7 +6937,7 @@
           <p:cNvPr id="14" name="">
             <a:extLst xmlns:a="http://schemas.openxmlformats.org/drawingml/2006/main">
               <a:ext uri="{FF2B5EF4-FFF2-40B4-BE49-F238E27FC236}">
-                <a16:creationId xmlns:a16="http://schemas.microsoft.com/office/drawing/2014/main" id="{FE83B4CE-9CB6-4B1F-A0DD-91B3887E7E4E}"/>
+                <a16:creationId xmlns:a16="http://schemas.microsoft.com/office/drawing/2014/main" id="{5FB0AABD-DED9-4FA3-8685-AD9688B30D24}"/>
               </a:ext>
             </a:extLst>
           </p:cNvPr>
@@ -7122,7 +6997,7 @@
           <p:cNvPr id="15" name="">
             <a:extLst xmlns:a="http://schemas.openxmlformats.org/drawingml/2006/main">
               <a:ext uri="{FF2B5EF4-FFF2-40B4-BE49-F238E27FC236}">
-                <a16:creationId xmlns:a16="http://schemas.microsoft.com/office/drawing/2014/main" id="{2225BB02-017E-47C9-B571-079205849F42}"/>
+                <a16:creationId xmlns:a16="http://schemas.microsoft.com/office/drawing/2014/main" id="{B60D99C4-108A-47D8-A65D-F04568CBC8FA}"/>
               </a:ext>
             </a:extLst>
           </p:cNvPr>
@@ -7153,7 +7028,7 @@
           <p:cNvPr id="16" name="source-footer">
             <a:extLst xmlns:a="http://schemas.openxmlformats.org/drawingml/2006/main">
               <a:ext uri="{FF2B5EF4-FFF2-40B4-BE49-F238E27FC236}">
-                <a16:creationId xmlns:a16="http://schemas.microsoft.com/office/drawing/2014/main" id="{5A1E3966-8309-4850-ADE6-B5EAF32F8EE2}"/>
+                <a16:creationId xmlns:a16="http://schemas.microsoft.com/office/drawing/2014/main" id="{85D3E0F8-5DB2-4A54-854B-1EE026A25D07}"/>
               </a:ext>
             </a:extLst>
           </p:cNvPr>
@@ -7209,7 +7084,7 @@
           <p:cNvPr id="17" name="slide-number">
             <a:extLst xmlns:a="http://schemas.openxmlformats.org/drawingml/2006/main">
               <a:ext uri="{FF2B5EF4-FFF2-40B4-BE49-F238E27FC236}">
-                <a16:creationId xmlns:a16="http://schemas.microsoft.com/office/drawing/2014/main" id="{62880447-9547-499E-9F9A-EAB07E2BD368}"/>
+                <a16:creationId xmlns:a16="http://schemas.microsoft.com/office/drawing/2014/main" id="{C625993B-D024-4524-A3BC-759DA1BC7817}"/>
               </a:ext>
             </a:extLst>
           </p:cNvPr>
@@ -7263,7 +7138,7 @@
     </p:spTree>
     <p:extLst>
       <p:ext uri="{BB962C8B-B14F-4D97-AF65-F5344CB8AC3E}">
-        <p14:creationId xmlns:p14="http://schemas.microsoft.com/office/powerpoint/2010/main" val="1922383852"/>
+        <p14:creationId xmlns:p14="http://schemas.microsoft.com/office/powerpoint/2010/main" val="1174671327"/>
       </p:ext>
     </p:extLst>
   </p:cSld>
@@ -7294,7 +7169,7 @@
           <p:cNvPr id="19" name="slide-title">
             <a:extLst xmlns:a="http://schemas.openxmlformats.org/drawingml/2006/main">
               <a:ext uri="{FF2B5EF4-FFF2-40B4-BE49-F238E27FC236}">
-                <a16:creationId xmlns:a16="http://schemas.microsoft.com/office/drawing/2014/main" id="{51B8E951-EE6F-492B-B22A-E3831A5A7639}"/>
+                <a16:creationId xmlns:a16="http://schemas.microsoft.com/office/drawing/2014/main" id="{02290894-A45A-4C1C-83FD-5C6D7E54A7F9}"/>
               </a:ext>
             </a:extLst>
           </p:cNvPr>
@@ -7350,7 +7225,7 @@
           <p:cNvPr id="2" name="">
             <a:extLst xmlns:a="http://schemas.openxmlformats.org/drawingml/2006/main">
               <a:ext uri="{FF2B5EF4-FFF2-40B4-BE49-F238E27FC236}">
-                <a16:creationId xmlns:a16="http://schemas.microsoft.com/office/drawing/2014/main" id="{3B202719-6F6C-4BE3-8E5C-34C435F8874B}"/>
+                <a16:creationId xmlns:a16="http://schemas.microsoft.com/office/drawing/2014/main" id="{11488FE8-FBED-4270-B21A-4D2A51870AFF}"/>
               </a:ext>
             </a:extLst>
           </p:cNvPr>
@@ -7381,7 +7256,7 @@
           <p:cNvPr id="3" name="">
             <a:extLst xmlns:a="http://schemas.openxmlformats.org/drawingml/2006/main">
               <a:ext uri="{FF2B5EF4-FFF2-40B4-BE49-F238E27FC236}">
-                <a16:creationId xmlns:a16="http://schemas.microsoft.com/office/drawing/2014/main" id="{CA6C5BA7-BA7E-4757-9862-17578DFB25F0}"/>
+                <a16:creationId xmlns:a16="http://schemas.microsoft.com/office/drawing/2014/main" id="{33004DF8-E151-4471-8832-5590D6DD6F7E}"/>
               </a:ext>
             </a:extLst>
           </p:cNvPr>
@@ -7437,7 +7312,7 @@
           <p:cNvPr id="4" name="">
             <a:extLst xmlns:a="http://schemas.openxmlformats.org/drawingml/2006/main">
               <a:ext uri="{FF2B5EF4-FFF2-40B4-BE49-F238E27FC236}">
-                <a16:creationId xmlns:a16="http://schemas.microsoft.com/office/drawing/2014/main" id="{9766FECA-B362-4FEA-A078-1985300D30E6}"/>
+                <a16:creationId xmlns:a16="http://schemas.microsoft.com/office/drawing/2014/main" id="{04904BB0-EDAE-4006-8D10-FF661EF1C976}"/>
               </a:ext>
             </a:extLst>
           </p:cNvPr>
@@ -7493,7 +7368,7 @@
           <p:cNvPr id="5" name="">
             <a:extLst xmlns:a="http://schemas.openxmlformats.org/drawingml/2006/main">
               <a:ext uri="{FF2B5EF4-FFF2-40B4-BE49-F238E27FC236}">
-                <a16:creationId xmlns:a16="http://schemas.microsoft.com/office/drawing/2014/main" id="{57A88B00-F6A5-4CF4-8C55-F2DE632AE954}"/>
+                <a16:creationId xmlns:a16="http://schemas.microsoft.com/office/drawing/2014/main" id="{1986B36D-2C7C-472F-A18B-1700D6D8622D}"/>
               </a:ext>
             </a:extLst>
           </p:cNvPr>
@@ -7549,7 +7424,7 @@
           <p:cNvPr id="6" name="">
             <a:extLst xmlns:a="http://schemas.openxmlformats.org/drawingml/2006/main">
               <a:ext uri="{FF2B5EF4-FFF2-40B4-BE49-F238E27FC236}">
-                <a16:creationId xmlns:a16="http://schemas.microsoft.com/office/drawing/2014/main" id="{5241E4DC-33F9-4FBF-90EC-AC06DBC03A0C}"/>
+                <a16:creationId xmlns:a16="http://schemas.microsoft.com/office/drawing/2014/main" id="{D3689B9F-D8C3-4F43-B2AA-55D5FD099026}"/>
               </a:ext>
             </a:extLst>
           </p:cNvPr>
@@ -7582,7 +7457,7 @@
           <p:cNvPr id="7" name="">
             <a:extLst xmlns:a="http://schemas.openxmlformats.org/drawingml/2006/main">
               <a:ext uri="{FF2B5EF4-FFF2-40B4-BE49-F238E27FC236}">
-                <a16:creationId xmlns:a16="http://schemas.microsoft.com/office/drawing/2014/main" id="{F1F5BCA4-3B3D-424C-BC39-8622EC83337D}"/>
+                <a16:creationId xmlns:a16="http://schemas.microsoft.com/office/drawing/2014/main" id="{C20BF5E5-D5D2-49FD-A383-ED23B159D86C}"/>
               </a:ext>
             </a:extLst>
           </p:cNvPr>
@@ -7638,7 +7513,7 @@
           <p:cNvPr id="8" name="">
             <a:extLst xmlns:a="http://schemas.openxmlformats.org/drawingml/2006/main">
               <a:ext uri="{FF2B5EF4-FFF2-40B4-BE49-F238E27FC236}">
-                <a16:creationId xmlns:a16="http://schemas.microsoft.com/office/drawing/2014/main" id="{0F413059-F633-49CB-81DA-F437269794CD}"/>
+                <a16:creationId xmlns:a16="http://schemas.microsoft.com/office/drawing/2014/main" id="{D209B087-A0E3-4C0E-A759-48645E999704}"/>
               </a:ext>
             </a:extLst>
           </p:cNvPr>
@@ -7694,7 +7569,7 @@
           <p:cNvPr id="9" name="">
             <a:extLst xmlns:a="http://schemas.openxmlformats.org/drawingml/2006/main">
               <a:ext uri="{FF2B5EF4-FFF2-40B4-BE49-F238E27FC236}">
-                <a16:creationId xmlns:a16="http://schemas.microsoft.com/office/drawing/2014/main" id="{04C7BF1C-F735-4B97-8BD4-DF380F61C2A3}"/>
+                <a16:creationId xmlns:a16="http://schemas.microsoft.com/office/drawing/2014/main" id="{70EAC4FA-C274-4D26-82B5-6A6F5177FC35}"/>
               </a:ext>
             </a:extLst>
           </p:cNvPr>
@@ -7750,7 +7625,7 @@
           <p:cNvPr id="10" name="">
             <a:extLst xmlns:a="http://schemas.openxmlformats.org/drawingml/2006/main">
               <a:ext uri="{FF2B5EF4-FFF2-40B4-BE49-F238E27FC236}">
-                <a16:creationId xmlns:a16="http://schemas.microsoft.com/office/drawing/2014/main" id="{5971BA29-7185-404E-9FB2-170AA0A0750C}"/>
+                <a16:creationId xmlns:a16="http://schemas.microsoft.com/office/drawing/2014/main" id="{CC795FF0-FE9B-4B1F-9D08-9F69EAC9F58F}"/>
               </a:ext>
             </a:extLst>
           </p:cNvPr>
@@ -7806,7 +7681,7 @@
           <p:cNvPr id="11" name="">
             <a:extLst xmlns:a="http://schemas.openxmlformats.org/drawingml/2006/main">
               <a:ext uri="{FF2B5EF4-FFF2-40B4-BE49-F238E27FC236}">
-                <a16:creationId xmlns:a16="http://schemas.microsoft.com/office/drawing/2014/main" id="{8AD34328-0287-41E0-A83B-C3D7E81AF685}"/>
+                <a16:creationId xmlns:a16="http://schemas.microsoft.com/office/drawing/2014/main" id="{D5591A61-2AE7-4312-BA59-7A098BB1859B}"/>
               </a:ext>
             </a:extLst>
           </p:cNvPr>
@@ -7862,7 +7737,7 @@
           <p:cNvPr id="12" name="">
             <a:extLst xmlns:a="http://schemas.openxmlformats.org/drawingml/2006/main">
               <a:ext uri="{FF2B5EF4-FFF2-40B4-BE49-F238E27FC236}">
-                <a16:creationId xmlns:a16="http://schemas.microsoft.com/office/drawing/2014/main" id="{3243DE5F-71BC-43A2-9CF9-9C71F73E0400}"/>
+                <a16:creationId xmlns:a16="http://schemas.microsoft.com/office/drawing/2014/main" id="{2A7D89DC-AF74-4656-B9F1-BB3E0D9832A3}"/>
               </a:ext>
             </a:extLst>
           </p:cNvPr>
@@ -7918,7 +7793,7 @@
           <p:cNvPr id="13" name="">
             <a:extLst xmlns:a="http://schemas.openxmlformats.org/drawingml/2006/main">
               <a:ext uri="{FF2B5EF4-FFF2-40B4-BE49-F238E27FC236}">
-                <a16:creationId xmlns:a16="http://schemas.microsoft.com/office/drawing/2014/main" id="{EE8A5441-C230-42A7-8DE9-2F9624FEA0E4}"/>
+                <a16:creationId xmlns:a16="http://schemas.microsoft.com/office/drawing/2014/main" id="{13006F14-EA55-4B9B-9960-36BBE642032B}"/>
               </a:ext>
             </a:extLst>
           </p:cNvPr>
@@ -7974,7 +7849,7 @@
           <p:cNvPr id="14" name="">
             <a:extLst xmlns:a="http://schemas.openxmlformats.org/drawingml/2006/main">
               <a:ext uri="{FF2B5EF4-FFF2-40B4-BE49-F238E27FC236}">
-                <a16:creationId xmlns:a16="http://schemas.microsoft.com/office/drawing/2014/main" id="{42692B6C-FCA5-4772-A12C-68CA8C2D4C58}"/>
+                <a16:creationId xmlns:a16="http://schemas.microsoft.com/office/drawing/2014/main" id="{C3526088-947C-4A3F-A502-3EB84583583F}"/>
               </a:ext>
             </a:extLst>
           </p:cNvPr>
@@ -8030,7 +7905,7 @@
           <p:cNvPr id="15" name="">
             <a:extLst xmlns:a="http://schemas.openxmlformats.org/drawingml/2006/main">
               <a:ext uri="{FF2B5EF4-FFF2-40B4-BE49-F238E27FC236}">
-                <a16:creationId xmlns:a16="http://schemas.microsoft.com/office/drawing/2014/main" id="{C108E6FF-57A8-4AB7-BCF3-1DB43C55CF15}"/>
+                <a16:creationId xmlns:a16="http://schemas.microsoft.com/office/drawing/2014/main" id="{7A963EE1-294C-4719-8EF8-E2C581D122E2}"/>
               </a:ext>
             </a:extLst>
           </p:cNvPr>
@@ -8086,7 +7961,7 @@
           <p:cNvPr id="16" name="">
             <a:extLst xmlns:a="http://schemas.openxmlformats.org/drawingml/2006/main">
               <a:ext uri="{FF2B5EF4-FFF2-40B4-BE49-F238E27FC236}">
-                <a16:creationId xmlns:a16="http://schemas.microsoft.com/office/drawing/2014/main" id="{7CD13AB8-F3BB-4298-B7E1-958C099946F6}"/>
+                <a16:creationId xmlns:a16="http://schemas.microsoft.com/office/drawing/2014/main" id="{D798D09A-B62C-47B2-AD8B-A153BDD9446B}"/>
               </a:ext>
             </a:extLst>
           </p:cNvPr>
@@ -8117,7 +7992,7 @@
           <p:cNvPr id="17" name="source-footer">
             <a:extLst xmlns:a="http://schemas.openxmlformats.org/drawingml/2006/main">
               <a:ext uri="{FF2B5EF4-FFF2-40B4-BE49-F238E27FC236}">
-                <a16:creationId xmlns:a16="http://schemas.microsoft.com/office/drawing/2014/main" id="{BDEBAA8F-908D-41D8-9C1C-DEE4A0E1E78E}"/>
+                <a16:creationId xmlns:a16="http://schemas.microsoft.com/office/drawing/2014/main" id="{619CCE7F-06FC-4B6B-8437-0FAE75741B69}"/>
               </a:ext>
             </a:extLst>
           </p:cNvPr>
@@ -8173,7 +8048,7 @@
           <p:cNvPr id="18" name="slide-number">
             <a:extLst xmlns:a="http://schemas.openxmlformats.org/drawingml/2006/main">
               <a:ext uri="{FF2B5EF4-FFF2-40B4-BE49-F238E27FC236}">
-                <a16:creationId xmlns:a16="http://schemas.microsoft.com/office/drawing/2014/main" id="{B164D5AA-2176-451C-9AF9-CD7CEC06C255}"/>
+                <a16:creationId xmlns:a16="http://schemas.microsoft.com/office/drawing/2014/main" id="{CB2B72D2-B7E9-4DD3-BE83-3A1D9F349B09}"/>
               </a:ext>
             </a:extLst>
           </p:cNvPr>
@@ -8227,7 +8102,7 @@
     </p:spTree>
     <p:extLst>
       <p:ext uri="{BB962C8B-B14F-4D97-AF65-F5344CB8AC3E}">
-        <p14:creationId xmlns:p14="http://schemas.microsoft.com/office/powerpoint/2010/main" val="989066068"/>
+        <p14:creationId xmlns:p14="http://schemas.microsoft.com/office/powerpoint/2010/main" val="2047472838"/>
       </p:ext>
     </p:extLst>
   </p:cSld>
@@ -8255,10 +8130,10 @@
       </p:grpSpPr>
       <p:sp>
         <p:nvSpPr>
-          <p:cNvPr id="14" name="slide-title">
-            <a:extLst xmlns:a="http://schemas.openxmlformats.org/drawingml/2006/main">
-              <a:ext uri="{FF2B5EF4-FFF2-40B4-BE49-F238E27FC236}">
-                <a16:creationId xmlns:a16="http://schemas.microsoft.com/office/drawing/2014/main" id="{2BA857D5-B6EB-4D2D-99BB-29A7C2DD2B46}"/>
+          <p:cNvPr id="15" name="slide-title">
+            <a:extLst xmlns:a="http://schemas.openxmlformats.org/drawingml/2006/main">
+              <a:ext uri="{FF2B5EF4-FFF2-40B4-BE49-F238E27FC236}">
+                <a16:creationId xmlns:a16="http://schemas.microsoft.com/office/drawing/2014/main" id="{B74E388E-8665-4E1A-83DB-22EB1CD989BF}"/>
               </a:ext>
             </a:extLst>
           </p:cNvPr>
@@ -8314,7 +8189,7 @@
           <p:cNvPr id="2" name="">
             <a:extLst xmlns:a="http://schemas.openxmlformats.org/drawingml/2006/main">
               <a:ext uri="{FF2B5EF4-FFF2-40B4-BE49-F238E27FC236}">
-                <a16:creationId xmlns:a16="http://schemas.microsoft.com/office/drawing/2014/main" id="{651A05F8-022A-4002-95A6-195665F6230C}"/>
+                <a16:creationId xmlns:a16="http://schemas.microsoft.com/office/drawing/2014/main" id="{9AC7EACE-5BCC-4A99-8DC4-15CB2593F301}"/>
               </a:ext>
             </a:extLst>
           </p:cNvPr>
@@ -8340,9 +8215,65 @@
           </a:ln>
         </p:spPr>
       </p:sp>
+      <p:sp>
+        <p:nvSpPr>
+          <p:cNvPr id="3" name="">
+            <a:extLst xmlns:a="http://schemas.openxmlformats.org/drawingml/2006/main">
+              <a:ext uri="{FF2B5EF4-FFF2-40B4-BE49-F238E27FC236}">
+                <a16:creationId xmlns:a16="http://schemas.microsoft.com/office/drawing/2014/main" id="{8927D476-5A4B-44D1-8D40-CC056BBBEA24}"/>
+              </a:ext>
+            </a:extLst>
+          </p:cNvPr>
+          <p:cNvSpPr>
+            <a:spLocks xmlns:a="http://schemas.openxmlformats.org/drawingml/2006/main" noGrp="1"/>
+          </p:cNvSpPr>
+          <p:nvPr/>
+        </p:nvSpPr>
+        <p:spPr>
+          <a:xfrm xmlns:a="http://schemas.openxmlformats.org/drawingml/2006/main">
+            <a:off x="1047750" y="1562100"/>
+            <a:ext cx="3048000" cy="228600"/>
+          </a:xfrm>
+          <a:prstGeom xmlns:a="http://schemas.openxmlformats.org/drawingml/2006/main" prst="rect">
+            <a:avLst/>
+          </a:prstGeom>
+          <a:noFill xmlns:a="http://schemas.openxmlformats.org/drawingml/2006/main"/>
+          <a:ln xmlns:a="http://schemas.openxmlformats.org/drawingml/2006/main" w="0">
+            <a:noFill/>
+            <a:prstDash val="solid"/>
+          </a:ln>
+        </p:spPr>
+        <p:txBody>
+          <a:bodyPr xmlns:a="http://schemas.openxmlformats.org/drawingml/2006/main" lIns="0" tIns="0" rIns="0" bIns="0" anchor="t"/>
+          <a:lstStyle xmlns:a="http://schemas.openxmlformats.org/drawingml/2006/main"/>
+          <a:p xmlns:a="http://schemas.openxmlformats.org/drawingml/2006/main">
+            <a:pPr algn="l">
+              <a:defRPr sz="1200" b="1">
+                <a:solidFill>
+                  <a:srgbClr val="687783"/>
+                </a:solidFill>
+                <a:latin typeface="Aptos"/>
+                <a:ea typeface="Aptos"/>
+                <a:cs typeface="Aptos"/>
+              </a:defRPr>
+            </a:pPr>
+            <a:r>
+              <a:rPr sz="1200" b="1">
+                <a:solidFill>
+                  <a:srgbClr val="687783"/>
+                </a:solidFill>
+                <a:latin typeface="Aptos"/>
+                <a:ea typeface="Aptos"/>
+                <a:cs typeface="Aptos"/>
+              </a:rPr>
+              <a:t>Mean waiting time (days)</a:t>
+            </a:r>
+          </a:p>
+        </p:txBody>
+      </p:sp>
       <p:graphicFrame>
         <p:nvGraphicFramePr>
-          <p:cNvPr id="16" name="Chart"/>
+          <p:cNvPr id="18" name="Chart"/>
           <p:cNvGraphicFramePr/>
           <p:nvPr/>
         </p:nvGraphicFramePr>
@@ -8352,16 +8283,16 @@
         </p:xfrm>
         <a:graphic xmlns:a="http://schemas.openxmlformats.org/drawingml/2006/main">
           <a:graphicData uri="http://schemas.openxmlformats.org/drawingml/2006/chart">
-            <c:chart xmlns:r="http://schemas.openxmlformats.org/officeDocument/2006/relationships" xmlns:c="http://schemas.openxmlformats.org/drawingml/2006/chart" r:id="Ra8680cb88d944a80"/>
+            <c:chart xmlns:r="http://schemas.openxmlformats.org/officeDocument/2006/relationships" xmlns:c="http://schemas.openxmlformats.org/drawingml/2006/chart" r:id="Rd9c4b45994064e16"/>
           </a:graphicData>
         </a:graphic>
       </p:graphicFrame>
       <p:sp>
         <p:nvSpPr>
-          <p:cNvPr id="4" name="">
-            <a:extLst xmlns:a="http://schemas.openxmlformats.org/drawingml/2006/main">
-              <a:ext uri="{FF2B5EF4-FFF2-40B4-BE49-F238E27FC236}">
-                <a16:creationId xmlns:a16="http://schemas.microsoft.com/office/drawing/2014/main" id="{96576666-04EA-4C47-8425-6324E2028CF0}"/>
+          <p:cNvPr id="5" name="">
+            <a:extLst xmlns:a="http://schemas.openxmlformats.org/drawingml/2006/main">
+              <a:ext uri="{FF2B5EF4-FFF2-40B4-BE49-F238E27FC236}">
+                <a16:creationId xmlns:a16="http://schemas.microsoft.com/office/drawing/2014/main" id="{F142B7BA-065C-4ECE-9C59-D9209BE22847}"/>
               </a:ext>
             </a:extLst>
           </p:cNvPr>
@@ -8391,10 +8322,10 @@
       </p:sp>
       <p:sp>
         <p:nvSpPr>
-          <p:cNvPr id="5" name="">
-            <a:extLst xmlns:a="http://schemas.openxmlformats.org/drawingml/2006/main">
-              <a:ext uri="{FF2B5EF4-FFF2-40B4-BE49-F238E27FC236}">
-                <a16:creationId xmlns:a16="http://schemas.microsoft.com/office/drawing/2014/main" id="{D2E94EF6-DE04-4143-AD27-BAAC7201555B}"/>
+          <p:cNvPr id="6" name="">
+            <a:extLst xmlns:a="http://schemas.openxmlformats.org/drawingml/2006/main">
+              <a:ext uri="{FF2B5EF4-FFF2-40B4-BE49-F238E27FC236}">
+                <a16:creationId xmlns:a16="http://schemas.microsoft.com/office/drawing/2014/main" id="{5458E5F4-67CA-4DD4-B991-9A8CABA543E8}"/>
               </a:ext>
             </a:extLst>
           </p:cNvPr>
@@ -8447,10 +8378,10 @@
       </p:sp>
       <p:sp>
         <p:nvSpPr>
-          <p:cNvPr id="6" name="">
-            <a:extLst xmlns:a="http://schemas.openxmlformats.org/drawingml/2006/main">
-              <a:ext uri="{FF2B5EF4-FFF2-40B4-BE49-F238E27FC236}">
-                <a16:creationId xmlns:a16="http://schemas.microsoft.com/office/drawing/2014/main" id="{597C9051-4A27-4B4A-AEC8-5D2493FF4C08}"/>
+          <p:cNvPr id="7" name="">
+            <a:extLst xmlns:a="http://schemas.openxmlformats.org/drawingml/2006/main">
+              <a:ext uri="{FF2B5EF4-FFF2-40B4-BE49-F238E27FC236}">
+                <a16:creationId xmlns:a16="http://schemas.microsoft.com/office/drawing/2014/main" id="{7ACD9A9C-AEFB-44E8-8E49-0CFF139C6A7D}"/>
               </a:ext>
             </a:extLst>
           </p:cNvPr>
@@ -8503,10 +8434,10 @@
       </p:sp>
       <p:sp>
         <p:nvSpPr>
-          <p:cNvPr id="7" name="">
-            <a:extLst xmlns:a="http://schemas.openxmlformats.org/drawingml/2006/main">
-              <a:ext uri="{FF2B5EF4-FFF2-40B4-BE49-F238E27FC236}">
-                <a16:creationId xmlns:a16="http://schemas.microsoft.com/office/drawing/2014/main" id="{1F813C47-AA88-4685-B123-53775B53D3D8}"/>
+          <p:cNvPr id="8" name="">
+            <a:extLst xmlns:a="http://schemas.openxmlformats.org/drawingml/2006/main">
+              <a:ext uri="{FF2B5EF4-FFF2-40B4-BE49-F238E27FC236}">
+                <a16:creationId xmlns:a16="http://schemas.microsoft.com/office/drawing/2014/main" id="{C0E78755-DDEC-467F-AF02-07FF194D0279}"/>
               </a:ext>
             </a:extLst>
           </p:cNvPr>
@@ -8582,10 +8513,10 @@
       </p:sp>
       <p:sp>
         <p:nvSpPr>
-          <p:cNvPr id="8" name="">
-            <a:extLst xmlns:a="http://schemas.openxmlformats.org/drawingml/2006/main">
-              <a:ext uri="{FF2B5EF4-FFF2-40B4-BE49-F238E27FC236}">
-                <a16:creationId xmlns:a16="http://schemas.microsoft.com/office/drawing/2014/main" id="{0701697E-2E27-4D93-A5E7-F32B9A5E1976}"/>
+          <p:cNvPr id="9" name="">
+            <a:extLst xmlns:a="http://schemas.openxmlformats.org/drawingml/2006/main">
+              <a:ext uri="{FF2B5EF4-FFF2-40B4-BE49-F238E27FC236}">
+                <a16:creationId xmlns:a16="http://schemas.microsoft.com/office/drawing/2014/main" id="{752C1086-7E1A-40CD-8A98-4628721AD8EC}"/>
               </a:ext>
             </a:extLst>
           </p:cNvPr>
@@ -8615,10 +8546,10 @@
       </p:sp>
       <p:sp>
         <p:nvSpPr>
-          <p:cNvPr id="9" name="">
-            <a:extLst xmlns:a="http://schemas.openxmlformats.org/drawingml/2006/main">
-              <a:ext uri="{FF2B5EF4-FFF2-40B4-BE49-F238E27FC236}">
-                <a16:creationId xmlns:a16="http://schemas.microsoft.com/office/drawing/2014/main" id="{72A94C66-F856-4C4D-919A-EBE36844A6C8}"/>
+          <p:cNvPr id="10" name="">
+            <a:extLst xmlns:a="http://schemas.openxmlformats.org/drawingml/2006/main">
+              <a:ext uri="{FF2B5EF4-FFF2-40B4-BE49-F238E27FC236}">
+                <a16:creationId xmlns:a16="http://schemas.microsoft.com/office/drawing/2014/main" id="{019089C3-5267-4E6B-A032-A7EE8990287F}"/>
               </a:ext>
             </a:extLst>
           </p:cNvPr>
@@ -8671,10 +8602,10 @@
       </p:sp>
       <p:sp>
         <p:nvSpPr>
-          <p:cNvPr id="10" name="">
-            <a:extLst xmlns:a="http://schemas.openxmlformats.org/drawingml/2006/main">
-              <a:ext uri="{FF2B5EF4-FFF2-40B4-BE49-F238E27FC236}">
-                <a16:creationId xmlns:a16="http://schemas.microsoft.com/office/drawing/2014/main" id="{51AAF1FB-3D91-4B94-A4C1-E09F16C6276D}"/>
+          <p:cNvPr id="11" name="">
+            <a:extLst xmlns:a="http://schemas.openxmlformats.org/drawingml/2006/main">
+              <a:ext uri="{FF2B5EF4-FFF2-40B4-BE49-F238E27FC236}">
+                <a16:creationId xmlns:a16="http://schemas.microsoft.com/office/drawing/2014/main" id="{6C4362DD-C844-4797-807D-BE8C9B47BCFA}"/>
               </a:ext>
             </a:extLst>
           </p:cNvPr>
@@ -8750,10 +8681,10 @@
       </p:sp>
       <p:sp>
         <p:nvSpPr>
-          <p:cNvPr id="11" name="">
-            <a:extLst xmlns:a="http://schemas.openxmlformats.org/drawingml/2006/main">
-              <a:ext uri="{FF2B5EF4-FFF2-40B4-BE49-F238E27FC236}">
-                <a16:creationId xmlns:a16="http://schemas.microsoft.com/office/drawing/2014/main" id="{588F4FB6-EE52-4CC7-8892-365D140258F3}"/>
+          <p:cNvPr id="12" name="">
+            <a:extLst xmlns:a="http://schemas.openxmlformats.org/drawingml/2006/main">
+              <a:ext uri="{FF2B5EF4-FFF2-40B4-BE49-F238E27FC236}">
+                <a16:creationId xmlns:a16="http://schemas.microsoft.com/office/drawing/2014/main" id="{877DE7BD-AC82-4B00-8125-FDE0E41C608B}"/>
               </a:ext>
             </a:extLst>
           </p:cNvPr>
@@ -8781,10 +8712,10 @@
       </p:sp>
       <p:sp>
         <p:nvSpPr>
-          <p:cNvPr id="12" name="source-footer">
-            <a:extLst xmlns:a="http://schemas.openxmlformats.org/drawingml/2006/main">
-              <a:ext uri="{FF2B5EF4-FFF2-40B4-BE49-F238E27FC236}">
-                <a16:creationId xmlns:a16="http://schemas.microsoft.com/office/drawing/2014/main" id="{29B3A706-F8E8-488D-B332-77FBB8E27DB4}"/>
+          <p:cNvPr id="13" name="source-footer">
+            <a:extLst xmlns:a="http://schemas.openxmlformats.org/drawingml/2006/main">
+              <a:ext uri="{FF2B5EF4-FFF2-40B4-BE49-F238E27FC236}">
+                <a16:creationId xmlns:a16="http://schemas.microsoft.com/office/drawing/2014/main" id="{93DB9D0F-C26A-4C13-B13F-B168E1ABCDBD}"/>
               </a:ext>
             </a:extLst>
           </p:cNvPr>
@@ -8837,10 +8768,10 @@
       </p:sp>
       <p:sp>
         <p:nvSpPr>
-          <p:cNvPr id="13" name="slide-number">
-            <a:extLst xmlns:a="http://schemas.openxmlformats.org/drawingml/2006/main">
-              <a:ext uri="{FF2B5EF4-FFF2-40B4-BE49-F238E27FC236}">
-                <a16:creationId xmlns:a16="http://schemas.microsoft.com/office/drawing/2014/main" id="{818A11ED-B906-4F46-A7EC-9D684B4D93BB}"/>
+          <p:cNvPr id="14" name="slide-number">
+            <a:extLst xmlns:a="http://schemas.openxmlformats.org/drawingml/2006/main">
+              <a:ext uri="{FF2B5EF4-FFF2-40B4-BE49-F238E27FC236}">
+                <a16:creationId xmlns:a16="http://schemas.microsoft.com/office/drawing/2014/main" id="{8ADE92F0-CFA6-45B2-8778-32368DF17C5D}"/>
               </a:ext>
             </a:extLst>
           </p:cNvPr>
@@ -8894,7 +8825,7 @@
     </p:spTree>
     <p:extLst>
       <p:ext uri="{BB962C8B-B14F-4D97-AF65-F5344CB8AC3E}">
-        <p14:creationId xmlns:p14="http://schemas.microsoft.com/office/powerpoint/2010/main" val="986369129"/>
+        <p14:creationId xmlns:p14="http://schemas.microsoft.com/office/powerpoint/2010/main" val="1647304205"/>
       </p:ext>
     </p:extLst>
   </p:cSld>
@@ -8925,7 +8856,7 @@
           <p:cNvPr id="30" name="slide-title">
             <a:extLst xmlns:a="http://schemas.openxmlformats.org/drawingml/2006/main">
               <a:ext uri="{FF2B5EF4-FFF2-40B4-BE49-F238E27FC236}">
-                <a16:creationId xmlns:a16="http://schemas.microsoft.com/office/drawing/2014/main" id="{5EE55A01-91CF-4F43-B7C3-2B4DC98C4382}"/>
+                <a16:creationId xmlns:a16="http://schemas.microsoft.com/office/drawing/2014/main" id="{DC5B9A1A-AE9A-4E76-A254-4495778056DB}"/>
               </a:ext>
             </a:extLst>
           </p:cNvPr>
@@ -8981,7 +8912,7 @@
           <p:cNvPr id="2" name="">
             <a:extLst xmlns:a="http://schemas.openxmlformats.org/drawingml/2006/main">
               <a:ext uri="{FF2B5EF4-FFF2-40B4-BE49-F238E27FC236}">
-                <a16:creationId xmlns:a16="http://schemas.microsoft.com/office/drawing/2014/main" id="{9CE6C26E-39E8-41C1-87F7-3BCA8B0CE1F0}"/>
+                <a16:creationId xmlns:a16="http://schemas.microsoft.com/office/drawing/2014/main" id="{331FEA1C-6FB9-4F7C-A4B9-283C38022A4A}"/>
               </a:ext>
             </a:extLst>
           </p:cNvPr>
@@ -9012,7 +8943,7 @@
           <p:cNvPr id="3" name="flow-box-1">
             <a:extLst xmlns:a="http://schemas.openxmlformats.org/drawingml/2006/main">
               <a:ext uri="{FF2B5EF4-FFF2-40B4-BE49-F238E27FC236}">
-                <a16:creationId xmlns:a16="http://schemas.microsoft.com/office/drawing/2014/main" id="{E644AE13-20FB-4BF7-B50A-9861E5219355}"/>
+                <a16:creationId xmlns:a16="http://schemas.microsoft.com/office/drawing/2014/main" id="{49F2FFED-2AD2-4A3C-86C4-C418EC85DF80}"/>
               </a:ext>
             </a:extLst>
           </p:cNvPr>
@@ -9047,7 +8978,7 @@
           <p:cNvPr id="4" name="flow-box-2">
             <a:extLst xmlns:a="http://schemas.openxmlformats.org/drawingml/2006/main">
               <a:ext uri="{FF2B5EF4-FFF2-40B4-BE49-F238E27FC236}">
-                <a16:creationId xmlns:a16="http://schemas.microsoft.com/office/drawing/2014/main" id="{F6FE3F98-0FFB-4672-85EF-DCD2E36BB3FC}"/>
+                <a16:creationId xmlns:a16="http://schemas.microsoft.com/office/drawing/2014/main" id="{619902E3-DDD5-4793-9C01-45236ECCEA72}"/>
               </a:ext>
             </a:extLst>
           </p:cNvPr>
@@ -9082,7 +9013,7 @@
           <p:cNvPr id="5" name="flow-box-3">
             <a:extLst xmlns:a="http://schemas.openxmlformats.org/drawingml/2006/main">
               <a:ext uri="{FF2B5EF4-FFF2-40B4-BE49-F238E27FC236}">
-                <a16:creationId xmlns:a16="http://schemas.microsoft.com/office/drawing/2014/main" id="{DC8BD236-D3BD-4E6B-BF6A-9B11E3428E21}"/>
+                <a16:creationId xmlns:a16="http://schemas.microsoft.com/office/drawing/2014/main" id="{3CF95049-B5E4-4017-9A6D-074D36B14F64}"/>
               </a:ext>
             </a:extLst>
           </p:cNvPr>
@@ -9117,7 +9048,7 @@
           <p:cNvPr id="6" name="flow-box-4">
             <a:extLst xmlns:a="http://schemas.openxmlformats.org/drawingml/2006/main">
               <a:ext uri="{FF2B5EF4-FFF2-40B4-BE49-F238E27FC236}">
-                <a16:creationId xmlns:a16="http://schemas.microsoft.com/office/drawing/2014/main" id="{439597A3-2E58-4292-862A-A61699BDAD2E}"/>
+                <a16:creationId xmlns:a16="http://schemas.microsoft.com/office/drawing/2014/main" id="{5209DEFE-ED11-4E04-A96A-8B4F711F3F22}"/>
               </a:ext>
             </a:extLst>
           </p:cNvPr>
@@ -9230,7 +9161,7 @@
           <p:cNvPr id="10" name="">
             <a:extLst xmlns:a="http://schemas.openxmlformats.org/drawingml/2006/main">
               <a:ext uri="{FF2B5EF4-FFF2-40B4-BE49-F238E27FC236}">
-                <a16:creationId xmlns:a16="http://schemas.microsoft.com/office/drawing/2014/main" id="{A8BFF0AB-BA1C-4C1E-A380-0043E2E51CAE}"/>
+                <a16:creationId xmlns:a16="http://schemas.microsoft.com/office/drawing/2014/main" id="{788F2037-AEA4-4873-A011-5D250E4AC430}"/>
               </a:ext>
             </a:extLst>
           </p:cNvPr>
@@ -9286,7 +9217,7 @@
           <p:cNvPr id="11" name="">
             <a:extLst xmlns:a="http://schemas.openxmlformats.org/drawingml/2006/main">
               <a:ext uri="{FF2B5EF4-FFF2-40B4-BE49-F238E27FC236}">
-                <a16:creationId xmlns:a16="http://schemas.microsoft.com/office/drawing/2014/main" id="{E5BF3D6A-7DEF-4B0E-AEB6-91C8D5C9A892}"/>
+                <a16:creationId xmlns:a16="http://schemas.microsoft.com/office/drawing/2014/main" id="{74DCE023-2A53-4939-8537-5314F1EAE5E2}"/>
               </a:ext>
             </a:extLst>
           </p:cNvPr>
@@ -9365,7 +9296,7 @@
           <p:cNvPr id="12" name="">
             <a:extLst xmlns:a="http://schemas.openxmlformats.org/drawingml/2006/main">
               <a:ext uri="{FF2B5EF4-FFF2-40B4-BE49-F238E27FC236}">
-                <a16:creationId xmlns:a16="http://schemas.microsoft.com/office/drawing/2014/main" id="{FEC67599-EB39-4EDF-B18C-F0A000ACCEE3}"/>
+                <a16:creationId xmlns:a16="http://schemas.microsoft.com/office/drawing/2014/main" id="{31448652-1F47-44BF-8D1D-4AACF2A92DA3}"/>
               </a:ext>
             </a:extLst>
           </p:cNvPr>
@@ -9421,7 +9352,7 @@
           <p:cNvPr id="13" name="">
             <a:extLst xmlns:a="http://schemas.openxmlformats.org/drawingml/2006/main">
               <a:ext uri="{FF2B5EF4-FFF2-40B4-BE49-F238E27FC236}">
-                <a16:creationId xmlns:a16="http://schemas.microsoft.com/office/drawing/2014/main" id="{23FBE793-6AB8-4953-AA8A-D8FA28E61AC8}"/>
+                <a16:creationId xmlns:a16="http://schemas.microsoft.com/office/drawing/2014/main" id="{ED4B845E-0714-44A3-89E3-069132EC3324}"/>
               </a:ext>
             </a:extLst>
           </p:cNvPr>
@@ -9477,7 +9408,7 @@
           <p:cNvPr id="14" name="">
             <a:extLst xmlns:a="http://schemas.openxmlformats.org/drawingml/2006/main">
               <a:ext uri="{FF2B5EF4-FFF2-40B4-BE49-F238E27FC236}">
-                <a16:creationId xmlns:a16="http://schemas.microsoft.com/office/drawing/2014/main" id="{230E23BE-0BDD-4AB2-A329-2ADEACB6207C}"/>
+                <a16:creationId xmlns:a16="http://schemas.microsoft.com/office/drawing/2014/main" id="{D627725A-D80D-48D5-995D-8016F7A4025C}"/>
               </a:ext>
             </a:extLst>
           </p:cNvPr>
@@ -9533,7 +9464,7 @@
           <p:cNvPr id="15" name="">
             <a:extLst xmlns:a="http://schemas.openxmlformats.org/drawingml/2006/main">
               <a:ext uri="{FF2B5EF4-FFF2-40B4-BE49-F238E27FC236}">
-                <a16:creationId xmlns:a16="http://schemas.microsoft.com/office/drawing/2014/main" id="{D0FBA842-7620-4E7B-8B43-3892FA65E38C}"/>
+                <a16:creationId xmlns:a16="http://schemas.microsoft.com/office/drawing/2014/main" id="{3C109D45-940C-461B-A134-A516DDEBB5D5}"/>
               </a:ext>
             </a:extLst>
           </p:cNvPr>
@@ -9589,7 +9520,7 @@
           <p:cNvPr id="16" name="">
             <a:extLst xmlns:a="http://schemas.openxmlformats.org/drawingml/2006/main">
               <a:ext uri="{FF2B5EF4-FFF2-40B4-BE49-F238E27FC236}">
-                <a16:creationId xmlns:a16="http://schemas.microsoft.com/office/drawing/2014/main" id="{BFCB7718-C57F-428A-A9FA-0EC493C4A08B}"/>
+                <a16:creationId xmlns:a16="http://schemas.microsoft.com/office/drawing/2014/main" id="{B2880909-B2C5-4FD1-8F4D-E34AF2A66061}"/>
               </a:ext>
             </a:extLst>
           </p:cNvPr>
@@ -9645,7 +9576,7 @@
           <p:cNvPr id="17" name="">
             <a:extLst xmlns:a="http://schemas.openxmlformats.org/drawingml/2006/main">
               <a:ext uri="{FF2B5EF4-FFF2-40B4-BE49-F238E27FC236}">
-                <a16:creationId xmlns:a16="http://schemas.microsoft.com/office/drawing/2014/main" id="{8ACE5B61-4B4E-4ACA-AB5A-7B7383D5544E}"/>
+                <a16:creationId xmlns:a16="http://schemas.microsoft.com/office/drawing/2014/main" id="{88DE0935-7845-4AB9-AE7C-FB409E8FD44F}"/>
               </a:ext>
             </a:extLst>
           </p:cNvPr>
@@ -9701,7 +9632,7 @@
           <p:cNvPr id="18" name="">
             <a:extLst xmlns:a="http://schemas.openxmlformats.org/drawingml/2006/main">
               <a:ext uri="{FF2B5EF4-FFF2-40B4-BE49-F238E27FC236}">
-                <a16:creationId xmlns:a16="http://schemas.microsoft.com/office/drawing/2014/main" id="{5C11F4B3-C794-401C-94A4-62BBA49EDAD0}"/>
+                <a16:creationId xmlns:a16="http://schemas.microsoft.com/office/drawing/2014/main" id="{7EC37CC0-344E-47FD-B8A8-C3E037C76270}"/>
               </a:ext>
             </a:extLst>
           </p:cNvPr>
@@ -9757,7 +9688,7 @@
           <p:cNvPr id="19" name="">
             <a:extLst xmlns:a="http://schemas.openxmlformats.org/drawingml/2006/main">
               <a:ext uri="{FF2B5EF4-FFF2-40B4-BE49-F238E27FC236}">
-                <a16:creationId xmlns:a16="http://schemas.microsoft.com/office/drawing/2014/main" id="{6F86B943-82F4-4784-90B4-CC823244E27C}"/>
+                <a16:creationId xmlns:a16="http://schemas.microsoft.com/office/drawing/2014/main" id="{810D12EE-040D-4508-AA37-C5F1BD670502}"/>
               </a:ext>
             </a:extLst>
           </p:cNvPr>
@@ -9813,7 +9744,7 @@
           <p:cNvPr id="20" name="">
             <a:extLst xmlns:a="http://schemas.openxmlformats.org/drawingml/2006/main">
               <a:ext uri="{FF2B5EF4-FFF2-40B4-BE49-F238E27FC236}">
-                <a16:creationId xmlns:a16="http://schemas.microsoft.com/office/drawing/2014/main" id="{9BB4F7DF-9D9E-458C-A060-4F005AD4A8C5}"/>
+                <a16:creationId xmlns:a16="http://schemas.microsoft.com/office/drawing/2014/main" id="{E38EEB51-63F6-4AD5-8150-CBA69E197D54}"/>
               </a:ext>
             </a:extLst>
           </p:cNvPr>
@@ -9869,7 +9800,7 @@
           <p:cNvPr id="21" name="">
             <a:extLst xmlns:a="http://schemas.openxmlformats.org/drawingml/2006/main">
               <a:ext uri="{FF2B5EF4-FFF2-40B4-BE49-F238E27FC236}">
-                <a16:creationId xmlns:a16="http://schemas.microsoft.com/office/drawing/2014/main" id="{045E2D6D-201E-4919-8AA0-63C56FF86365}"/>
+                <a16:creationId xmlns:a16="http://schemas.microsoft.com/office/drawing/2014/main" id="{26D93A73-9D97-4A6D-9834-8D12E019DA22}"/>
               </a:ext>
             </a:extLst>
           </p:cNvPr>
@@ -9925,7 +9856,7 @@
           <p:cNvPr id="22" name="">
             <a:extLst xmlns:a="http://schemas.openxmlformats.org/drawingml/2006/main">
               <a:ext uri="{FF2B5EF4-FFF2-40B4-BE49-F238E27FC236}">
-                <a16:creationId xmlns:a16="http://schemas.microsoft.com/office/drawing/2014/main" id="{3FBB4BBC-5C43-4B74-8E06-2B081AA14BE3}"/>
+                <a16:creationId xmlns:a16="http://schemas.microsoft.com/office/drawing/2014/main" id="{36FB4A13-B0CF-4137-B68F-9E752EEE645F}"/>
               </a:ext>
             </a:extLst>
           </p:cNvPr>
@@ -9981,7 +9912,7 @@
           <p:cNvPr id="23" name="">
             <a:extLst xmlns:a="http://schemas.openxmlformats.org/drawingml/2006/main">
               <a:ext uri="{FF2B5EF4-FFF2-40B4-BE49-F238E27FC236}">
-                <a16:creationId xmlns:a16="http://schemas.microsoft.com/office/drawing/2014/main" id="{054A0202-4755-4BFA-AC76-D445CC06A5DF}"/>
+                <a16:creationId xmlns:a16="http://schemas.microsoft.com/office/drawing/2014/main" id="{4FB85109-3CF0-497C-8D35-B9B2E0075CF9}"/>
               </a:ext>
             </a:extLst>
           </p:cNvPr>
@@ -10037,7 +9968,7 @@
           <p:cNvPr id="24" name="">
             <a:extLst xmlns:a="http://schemas.openxmlformats.org/drawingml/2006/main">
               <a:ext uri="{FF2B5EF4-FFF2-40B4-BE49-F238E27FC236}">
-                <a16:creationId xmlns:a16="http://schemas.microsoft.com/office/drawing/2014/main" id="{47F31DF9-AB3E-4E39-8A34-063191F1878F}"/>
+                <a16:creationId xmlns:a16="http://schemas.microsoft.com/office/drawing/2014/main" id="{6ACC4693-14B2-45C0-AE5F-8A482A83368A}"/>
               </a:ext>
             </a:extLst>
           </p:cNvPr>
@@ -10093,7 +10024,7 @@
           <p:cNvPr id="25" name="">
             <a:extLst xmlns:a="http://schemas.openxmlformats.org/drawingml/2006/main">
               <a:ext uri="{FF2B5EF4-FFF2-40B4-BE49-F238E27FC236}">
-                <a16:creationId xmlns:a16="http://schemas.microsoft.com/office/drawing/2014/main" id="{EA4FBD87-CA1F-45E0-8E08-FEA7E9C02213}"/>
+                <a16:creationId xmlns:a16="http://schemas.microsoft.com/office/drawing/2014/main" id="{83DA213C-DC73-4309-AD13-483B0C206962}"/>
               </a:ext>
             </a:extLst>
           </p:cNvPr>
@@ -10149,7 +10080,7 @@
           <p:cNvPr id="26" name="">
             <a:extLst xmlns:a="http://schemas.openxmlformats.org/drawingml/2006/main">
               <a:ext uri="{FF2B5EF4-FFF2-40B4-BE49-F238E27FC236}">
-                <a16:creationId xmlns:a16="http://schemas.microsoft.com/office/drawing/2014/main" id="{7A0E0268-034D-4ADF-B71A-12EE3DF3CD39}"/>
+                <a16:creationId xmlns:a16="http://schemas.microsoft.com/office/drawing/2014/main" id="{5A2EFD32-EDB6-4B41-AF12-C675B3B2FD4B}"/>
               </a:ext>
             </a:extLst>
           </p:cNvPr>
@@ -10209,7 +10140,7 @@
           <p:cNvPr id="27" name="">
             <a:extLst xmlns:a="http://schemas.openxmlformats.org/drawingml/2006/main">
               <a:ext uri="{FF2B5EF4-FFF2-40B4-BE49-F238E27FC236}">
-                <a16:creationId xmlns:a16="http://schemas.microsoft.com/office/drawing/2014/main" id="{BF5B47C2-4437-4F91-88B2-0E3FD87CA67E}"/>
+                <a16:creationId xmlns:a16="http://schemas.microsoft.com/office/drawing/2014/main" id="{4F0AB39F-8802-4CC0-9443-C7997012580C}"/>
               </a:ext>
             </a:extLst>
           </p:cNvPr>
@@ -10240,7 +10171,7 @@
           <p:cNvPr id="28" name="source-footer">
             <a:extLst xmlns:a="http://schemas.openxmlformats.org/drawingml/2006/main">
               <a:ext uri="{FF2B5EF4-FFF2-40B4-BE49-F238E27FC236}">
-                <a16:creationId xmlns:a16="http://schemas.microsoft.com/office/drawing/2014/main" id="{A6E59142-AA00-4890-A847-466EFA2E513E}"/>
+                <a16:creationId xmlns:a16="http://schemas.microsoft.com/office/drawing/2014/main" id="{752F4183-A6BD-4183-BD8C-8E2601C65E4A}"/>
               </a:ext>
             </a:extLst>
           </p:cNvPr>
@@ -10296,7 +10227,7 @@
           <p:cNvPr id="29" name="slide-number">
             <a:extLst xmlns:a="http://schemas.openxmlformats.org/drawingml/2006/main">
               <a:ext uri="{FF2B5EF4-FFF2-40B4-BE49-F238E27FC236}">
-                <a16:creationId xmlns:a16="http://schemas.microsoft.com/office/drawing/2014/main" id="{A857E71E-11C1-4D1F-8AEF-2ABBF9C36BF4}"/>
+                <a16:creationId xmlns:a16="http://schemas.microsoft.com/office/drawing/2014/main" id="{B1A3AA38-5DE6-4624-A09E-1D82AA85970C}"/>
               </a:ext>
             </a:extLst>
           </p:cNvPr>
@@ -10350,7 +10281,7 @@
     </p:spTree>
     <p:extLst>
       <p:ext uri="{BB962C8B-B14F-4D97-AF65-F5344CB8AC3E}">
-        <p14:creationId xmlns:p14="http://schemas.microsoft.com/office/powerpoint/2010/main" val="142044432"/>
+        <p14:creationId xmlns:p14="http://schemas.microsoft.com/office/powerpoint/2010/main" val="1530598789"/>
       </p:ext>
     </p:extLst>
   </p:cSld>
@@ -10381,7 +10312,7 @@
           <p:cNvPr id="19" name="slide-title">
             <a:extLst xmlns:a="http://schemas.openxmlformats.org/drawingml/2006/main">
               <a:ext uri="{FF2B5EF4-FFF2-40B4-BE49-F238E27FC236}">
-                <a16:creationId xmlns:a16="http://schemas.microsoft.com/office/drawing/2014/main" id="{7BE60B3A-92C8-4DD6-9416-5EBA3A481078}"/>
+                <a16:creationId xmlns:a16="http://schemas.microsoft.com/office/drawing/2014/main" id="{6206577B-2379-4032-9459-CFD6E4CBB750}"/>
               </a:ext>
             </a:extLst>
           </p:cNvPr>
@@ -10437,7 +10368,7 @@
           <p:cNvPr id="2" name="">
             <a:extLst xmlns:a="http://schemas.openxmlformats.org/drawingml/2006/main">
               <a:ext uri="{FF2B5EF4-FFF2-40B4-BE49-F238E27FC236}">
-                <a16:creationId xmlns:a16="http://schemas.microsoft.com/office/drawing/2014/main" id="{A63932C6-CF57-4E98-B344-8F92D7485666}"/>
+                <a16:creationId xmlns:a16="http://schemas.microsoft.com/office/drawing/2014/main" id="{6BC3D88E-F300-4841-B679-247E5256D68D}"/>
               </a:ext>
             </a:extLst>
           </p:cNvPr>
@@ -10468,7 +10399,7 @@
           <p:cNvPr id="3" name="">
             <a:extLst xmlns:a="http://schemas.openxmlformats.org/drawingml/2006/main">
               <a:ext uri="{FF2B5EF4-FFF2-40B4-BE49-F238E27FC236}">
-                <a16:creationId xmlns:a16="http://schemas.microsoft.com/office/drawing/2014/main" id="{9F8BBD5B-393E-4EDB-8EC8-BC555FFD84E0}"/>
+                <a16:creationId xmlns:a16="http://schemas.microsoft.com/office/drawing/2014/main" id="{B1BE60DC-1230-4FB6-9F63-134A9A5E3036}"/>
               </a:ext>
             </a:extLst>
           </p:cNvPr>
@@ -10524,7 +10455,7 @@
           <p:cNvPr id="4" name="">
             <a:extLst xmlns:a="http://schemas.openxmlformats.org/drawingml/2006/main">
               <a:ext uri="{FF2B5EF4-FFF2-40B4-BE49-F238E27FC236}">
-                <a16:creationId xmlns:a16="http://schemas.microsoft.com/office/drawing/2014/main" id="{01A707A7-730A-4844-AC01-D87576D21514}"/>
+                <a16:creationId xmlns:a16="http://schemas.microsoft.com/office/drawing/2014/main" id="{575A4C66-EA08-441E-AAAE-837A6C81889B}"/>
               </a:ext>
             </a:extLst>
           </p:cNvPr>
@@ -10580,7 +10511,7 @@
           <p:cNvPr id="5" name="">
             <a:extLst xmlns:a="http://schemas.openxmlformats.org/drawingml/2006/main">
               <a:ext uri="{FF2B5EF4-FFF2-40B4-BE49-F238E27FC236}">
-                <a16:creationId xmlns:a16="http://schemas.microsoft.com/office/drawing/2014/main" id="{F9BA5F21-E7D7-486A-BB62-7C3F06EE913B}"/>
+                <a16:creationId xmlns:a16="http://schemas.microsoft.com/office/drawing/2014/main" id="{33D8096C-E45C-4775-A7A5-4CBAD6E409CB}"/>
               </a:ext>
             </a:extLst>
           </p:cNvPr>
@@ -10636,7 +10567,7 @@
           <p:cNvPr id="6" name="">
             <a:extLst xmlns:a="http://schemas.openxmlformats.org/drawingml/2006/main">
               <a:ext uri="{FF2B5EF4-FFF2-40B4-BE49-F238E27FC236}">
-                <a16:creationId xmlns:a16="http://schemas.microsoft.com/office/drawing/2014/main" id="{DFD8AA1E-C3CA-434C-85D6-E012503D97AD}"/>
+                <a16:creationId xmlns:a16="http://schemas.microsoft.com/office/drawing/2014/main" id="{1E752DFA-27FA-40D6-ADDC-8ADCDB05D37B}"/>
               </a:ext>
             </a:extLst>
           </p:cNvPr>
@@ -10692,7 +10623,7 @@
           <p:cNvPr id="7" name="">
             <a:extLst xmlns:a="http://schemas.openxmlformats.org/drawingml/2006/main">
               <a:ext uri="{FF2B5EF4-FFF2-40B4-BE49-F238E27FC236}">
-                <a16:creationId xmlns:a16="http://schemas.microsoft.com/office/drawing/2014/main" id="{59DC6F81-6731-47B9-9376-ADD9FA430D2F}"/>
+                <a16:creationId xmlns:a16="http://schemas.microsoft.com/office/drawing/2014/main" id="{1DF89204-7D39-43EF-B991-68B7841720D0}"/>
               </a:ext>
             </a:extLst>
           </p:cNvPr>
@@ -10725,7 +10656,7 @@
           <p:cNvPr id="8" name="">
             <a:extLst xmlns:a="http://schemas.openxmlformats.org/drawingml/2006/main">
               <a:ext uri="{FF2B5EF4-FFF2-40B4-BE49-F238E27FC236}">
-                <a16:creationId xmlns:a16="http://schemas.microsoft.com/office/drawing/2014/main" id="{27434B0F-34A8-440D-A636-382B5F28BD7A}"/>
+                <a16:creationId xmlns:a16="http://schemas.microsoft.com/office/drawing/2014/main" id="{87B595D2-D8FA-43F4-81A2-AC82FC184926}"/>
               </a:ext>
             </a:extLst>
           </p:cNvPr>
@@ -10781,7 +10712,7 @@
           <p:cNvPr id="9" name="">
             <a:extLst xmlns:a="http://schemas.openxmlformats.org/drawingml/2006/main">
               <a:ext uri="{FF2B5EF4-FFF2-40B4-BE49-F238E27FC236}">
-                <a16:creationId xmlns:a16="http://schemas.microsoft.com/office/drawing/2014/main" id="{10CEB361-EBD6-4780-B310-C53826DFEC82}"/>
+                <a16:creationId xmlns:a16="http://schemas.microsoft.com/office/drawing/2014/main" id="{947EEC3F-92C1-440A-B14A-979DC6D82826}"/>
               </a:ext>
             </a:extLst>
           </p:cNvPr>
@@ -10837,7 +10768,7 @@
           <p:cNvPr id="10" name="">
             <a:extLst xmlns:a="http://schemas.openxmlformats.org/drawingml/2006/main">
               <a:ext uri="{FF2B5EF4-FFF2-40B4-BE49-F238E27FC236}">
-                <a16:creationId xmlns:a16="http://schemas.microsoft.com/office/drawing/2014/main" id="{EFECFEFB-E416-4A7F-A41B-48A0595D2F6A}"/>
+                <a16:creationId xmlns:a16="http://schemas.microsoft.com/office/drawing/2014/main" id="{C3DC85E4-6DFB-4BB3-9C12-95BFC73DA6F7}"/>
               </a:ext>
             </a:extLst>
           </p:cNvPr>
@@ -10893,7 +10824,7 @@
           <p:cNvPr id="11" name="">
             <a:extLst xmlns:a="http://schemas.openxmlformats.org/drawingml/2006/main">
               <a:ext uri="{FF2B5EF4-FFF2-40B4-BE49-F238E27FC236}">
-                <a16:creationId xmlns:a16="http://schemas.microsoft.com/office/drawing/2014/main" id="{FE4E3322-4CB2-4B14-B77D-DC27F90747EC}"/>
+                <a16:creationId xmlns:a16="http://schemas.microsoft.com/office/drawing/2014/main" id="{31AEBA04-B24B-43E4-A60D-590F9B326847}"/>
               </a:ext>
             </a:extLst>
           </p:cNvPr>
@@ -10949,7 +10880,7 @@
           <p:cNvPr id="12" name="">
             <a:extLst xmlns:a="http://schemas.openxmlformats.org/drawingml/2006/main">
               <a:ext uri="{FF2B5EF4-FFF2-40B4-BE49-F238E27FC236}">
-                <a16:creationId xmlns:a16="http://schemas.microsoft.com/office/drawing/2014/main" id="{A28BCF43-84D8-430C-8CC6-D663269F1A5C}"/>
+                <a16:creationId xmlns:a16="http://schemas.microsoft.com/office/drawing/2014/main" id="{A3384BCC-8F1E-4EA5-B93D-B3DF95512E63}"/>
               </a:ext>
             </a:extLst>
           </p:cNvPr>
@@ -11005,7 +10936,7 @@
           <p:cNvPr id="13" name="">
             <a:extLst xmlns:a="http://schemas.openxmlformats.org/drawingml/2006/main">
               <a:ext uri="{FF2B5EF4-FFF2-40B4-BE49-F238E27FC236}">
-                <a16:creationId xmlns:a16="http://schemas.microsoft.com/office/drawing/2014/main" id="{9DD8BC8A-B569-4E2D-A57F-7F7CC46ED7CC}"/>
+                <a16:creationId xmlns:a16="http://schemas.microsoft.com/office/drawing/2014/main" id="{841A9E58-8FF7-4AFF-9C7C-DD1DD0951CF8}"/>
               </a:ext>
             </a:extLst>
           </p:cNvPr>
@@ -11061,7 +10992,7 @@
           <p:cNvPr id="14" name="">
             <a:extLst xmlns:a="http://schemas.openxmlformats.org/drawingml/2006/main">
               <a:ext uri="{FF2B5EF4-FFF2-40B4-BE49-F238E27FC236}">
-                <a16:creationId xmlns:a16="http://schemas.microsoft.com/office/drawing/2014/main" id="{556FE661-B8EE-43FF-AF16-ADF44000AC5D}"/>
+                <a16:creationId xmlns:a16="http://schemas.microsoft.com/office/drawing/2014/main" id="{87C51430-987F-48DB-9247-4AA962CF88B8}"/>
               </a:ext>
             </a:extLst>
           </p:cNvPr>
@@ -11117,7 +11048,7 @@
           <p:cNvPr id="15" name="">
             <a:extLst xmlns:a="http://schemas.openxmlformats.org/drawingml/2006/main">
               <a:ext uri="{FF2B5EF4-FFF2-40B4-BE49-F238E27FC236}">
-                <a16:creationId xmlns:a16="http://schemas.microsoft.com/office/drawing/2014/main" id="{A5D711D7-10F8-4A2D-8459-0B4C51093287}"/>
+                <a16:creationId xmlns:a16="http://schemas.microsoft.com/office/drawing/2014/main" id="{051BA3F5-352A-4E2D-8A42-AC28E9CB9B02}"/>
               </a:ext>
             </a:extLst>
           </p:cNvPr>
@@ -11177,7 +11108,7 @@
           <p:cNvPr id="16" name="">
             <a:extLst xmlns:a="http://schemas.openxmlformats.org/drawingml/2006/main">
               <a:ext uri="{FF2B5EF4-FFF2-40B4-BE49-F238E27FC236}">
-                <a16:creationId xmlns:a16="http://schemas.microsoft.com/office/drawing/2014/main" id="{C56E569D-AFA1-4A05-A8CE-454189FCB59B}"/>
+                <a16:creationId xmlns:a16="http://schemas.microsoft.com/office/drawing/2014/main" id="{8BF5430C-E47E-45E4-8B69-42C5205E119A}"/>
               </a:ext>
             </a:extLst>
           </p:cNvPr>
@@ -11208,7 +11139,7 @@
           <p:cNvPr id="17" name="source-footer">
             <a:extLst xmlns:a="http://schemas.openxmlformats.org/drawingml/2006/main">
               <a:ext uri="{FF2B5EF4-FFF2-40B4-BE49-F238E27FC236}">
-                <a16:creationId xmlns:a16="http://schemas.microsoft.com/office/drawing/2014/main" id="{2B0DFF35-1C53-41C7-AE7C-8FAE1D11DB5F}"/>
+                <a16:creationId xmlns:a16="http://schemas.microsoft.com/office/drawing/2014/main" id="{8A5A708E-8FED-46C0-A921-D85714EA9165}"/>
               </a:ext>
             </a:extLst>
           </p:cNvPr>
@@ -11264,7 +11195,7 @@
           <p:cNvPr id="18" name="slide-number">
             <a:extLst xmlns:a="http://schemas.openxmlformats.org/drawingml/2006/main">
               <a:ext uri="{FF2B5EF4-FFF2-40B4-BE49-F238E27FC236}">
-                <a16:creationId xmlns:a16="http://schemas.microsoft.com/office/drawing/2014/main" id="{C0B9E1F3-1B2F-4A19-953D-9E6B7E59DA07}"/>
+                <a16:creationId xmlns:a16="http://schemas.microsoft.com/office/drawing/2014/main" id="{DBD928D1-C66A-49CC-9686-2EB48A8DAE20}"/>
               </a:ext>
             </a:extLst>
           </p:cNvPr>
@@ -11318,7 +11249,7 @@
     </p:spTree>
     <p:extLst>
       <p:ext uri="{BB962C8B-B14F-4D97-AF65-F5344CB8AC3E}">
-        <p14:creationId xmlns:p14="http://schemas.microsoft.com/office/powerpoint/2010/main" val="221134719"/>
+        <p14:creationId xmlns:p14="http://schemas.microsoft.com/office/powerpoint/2010/main" val="318143319"/>
       </p:ext>
     </p:extLst>
   </p:cSld>
@@ -11349,7 +11280,7 @@
           <p:cNvPr id="20" name="">
             <a:extLst xmlns:a="http://schemas.openxmlformats.org/drawingml/2006/main">
               <a:ext uri="{FF2B5EF4-FFF2-40B4-BE49-F238E27FC236}">
-                <a16:creationId xmlns:a16="http://schemas.microsoft.com/office/drawing/2014/main" id="{1C29023B-7BE4-4D14-A2F7-3BAEABDA06B1}"/>
+                <a16:creationId xmlns:a16="http://schemas.microsoft.com/office/drawing/2014/main" id="{9048C401-C051-45E4-B7B1-8D87B5822573}"/>
               </a:ext>
             </a:extLst>
           </p:cNvPr>
@@ -11405,7 +11336,7 @@
           <p:cNvPr id="2" name="">
             <a:extLst xmlns:a="http://schemas.openxmlformats.org/drawingml/2006/main">
               <a:ext uri="{FF2B5EF4-FFF2-40B4-BE49-F238E27FC236}">
-                <a16:creationId xmlns:a16="http://schemas.microsoft.com/office/drawing/2014/main" id="{B13A1EC3-7C66-49CA-A61D-3E7D050B9F9A}"/>
+                <a16:creationId xmlns:a16="http://schemas.microsoft.com/office/drawing/2014/main" id="{67DD9AC6-AA97-4485-9126-6304331890F9}"/>
               </a:ext>
             </a:extLst>
           </p:cNvPr>
@@ -11436,7 +11367,7 @@
           <p:cNvPr id="3" name="">
             <a:extLst xmlns:a="http://schemas.openxmlformats.org/drawingml/2006/main">
               <a:ext uri="{FF2B5EF4-FFF2-40B4-BE49-F238E27FC236}">
-                <a16:creationId xmlns:a16="http://schemas.microsoft.com/office/drawing/2014/main" id="{E150FF6E-168D-40A0-8CBE-A4246EE285A8}"/>
+                <a16:creationId xmlns:a16="http://schemas.microsoft.com/office/drawing/2014/main" id="{471B606A-CD67-4335-A392-7FE4FE157D31}"/>
               </a:ext>
             </a:extLst>
           </p:cNvPr>
@@ -11492,7 +11423,7 @@
           <p:cNvPr id="4" name="">
             <a:extLst xmlns:a="http://schemas.openxmlformats.org/drawingml/2006/main">
               <a:ext uri="{FF2B5EF4-FFF2-40B4-BE49-F238E27FC236}">
-                <a16:creationId xmlns:a16="http://schemas.microsoft.com/office/drawing/2014/main" id="{CB8C0CC9-F7DA-4F5F-B7C7-7209017BB5E0}"/>
+                <a16:creationId xmlns:a16="http://schemas.microsoft.com/office/drawing/2014/main" id="{6227F094-29D8-4E38-B41D-7C8524D07634}"/>
               </a:ext>
             </a:extLst>
           </p:cNvPr>
@@ -11548,7 +11479,7 @@
           <p:cNvPr id="5" name="">
             <a:extLst xmlns:a="http://schemas.openxmlformats.org/drawingml/2006/main">
               <a:ext uri="{FF2B5EF4-FFF2-40B4-BE49-F238E27FC236}">
-                <a16:creationId xmlns:a16="http://schemas.microsoft.com/office/drawing/2014/main" id="{DBEBC78A-08F4-4887-BF88-599B2EB428CD}"/>
+                <a16:creationId xmlns:a16="http://schemas.microsoft.com/office/drawing/2014/main" id="{F6CABFCE-6067-4CF1-9CE3-A6BE2CD979DA}"/>
               </a:ext>
             </a:extLst>
           </p:cNvPr>
@@ -11627,7 +11558,7 @@
           <p:cNvPr id="6" name="">
             <a:extLst xmlns:a="http://schemas.openxmlformats.org/drawingml/2006/main">
               <a:ext uri="{FF2B5EF4-FFF2-40B4-BE49-F238E27FC236}">
-                <a16:creationId xmlns:a16="http://schemas.microsoft.com/office/drawing/2014/main" id="{4682CBF3-29B8-409C-BCD0-77788F7305B4}"/>
+                <a16:creationId xmlns:a16="http://schemas.microsoft.com/office/drawing/2014/main" id="{C7F5C4CE-9BFA-4AC6-A2DF-1D9185507A91}"/>
               </a:ext>
             </a:extLst>
           </p:cNvPr>
@@ -11660,7 +11591,7 @@
           <p:cNvPr id="7" name="">
             <a:extLst xmlns:a="http://schemas.openxmlformats.org/drawingml/2006/main">
               <a:ext uri="{FF2B5EF4-FFF2-40B4-BE49-F238E27FC236}">
-                <a16:creationId xmlns:a16="http://schemas.microsoft.com/office/drawing/2014/main" id="{6425716D-00FD-49A9-8FCD-9927B8E87BE7}"/>
+                <a16:creationId xmlns:a16="http://schemas.microsoft.com/office/drawing/2014/main" id="{C8008E0D-EE08-40CA-BC81-D594C3A8CFB5}"/>
               </a:ext>
             </a:extLst>
           </p:cNvPr>
@@ -11716,7 +11647,7 @@
           <p:cNvPr id="8" name="">
             <a:extLst xmlns:a="http://schemas.openxmlformats.org/drawingml/2006/main">
               <a:ext uri="{FF2B5EF4-FFF2-40B4-BE49-F238E27FC236}">
-                <a16:creationId xmlns:a16="http://schemas.microsoft.com/office/drawing/2014/main" id="{AEBFFAD0-C33A-41D9-B93F-EB8FF6485738}"/>
+                <a16:creationId xmlns:a16="http://schemas.microsoft.com/office/drawing/2014/main" id="{23270D10-A607-4394-A439-E0AE05F2645A}"/>
               </a:ext>
             </a:extLst>
           </p:cNvPr>
@@ -11772,7 +11703,7 @@
           <p:cNvPr id="9" name="">
             <a:extLst xmlns:a="http://schemas.openxmlformats.org/drawingml/2006/main">
               <a:ext uri="{FF2B5EF4-FFF2-40B4-BE49-F238E27FC236}">
-                <a16:creationId xmlns:a16="http://schemas.microsoft.com/office/drawing/2014/main" id="{97FB2266-F447-4DC1-AE81-1241BF63528A}"/>
+                <a16:creationId xmlns:a16="http://schemas.microsoft.com/office/drawing/2014/main" id="{2C8F0CCE-8351-4BCF-8A0C-9394828140FA}"/>
               </a:ext>
             </a:extLst>
           </p:cNvPr>
@@ -11828,7 +11759,7 @@
           <p:cNvPr id="10" name="">
             <a:extLst xmlns:a="http://schemas.openxmlformats.org/drawingml/2006/main">
               <a:ext uri="{FF2B5EF4-FFF2-40B4-BE49-F238E27FC236}">
-                <a16:creationId xmlns:a16="http://schemas.microsoft.com/office/drawing/2014/main" id="{715A729E-5A0E-42CC-A4D2-48DB66652136}"/>
+                <a16:creationId xmlns:a16="http://schemas.microsoft.com/office/drawing/2014/main" id="{7A88EBA9-4D22-4E71-BF26-50D84EF037BD}"/>
               </a:ext>
             </a:extLst>
           </p:cNvPr>
@@ -11867,7 +11798,7 @@
           <p:cNvPr id="11" name="">
             <a:extLst xmlns:a="http://schemas.openxmlformats.org/drawingml/2006/main">
               <a:ext uri="{FF2B5EF4-FFF2-40B4-BE49-F238E27FC236}">
-                <a16:creationId xmlns:a16="http://schemas.microsoft.com/office/drawing/2014/main" id="{5B69EA9A-0ED1-4B02-AB7C-8B81BE47BD7C}"/>
+                <a16:creationId xmlns:a16="http://schemas.microsoft.com/office/drawing/2014/main" id="{E39F4CEC-6F85-48EB-99F1-F7DAC4BBF520}"/>
               </a:ext>
             </a:extLst>
           </p:cNvPr>
@@ -11923,7 +11854,7 @@
           <p:cNvPr id="12" name="">
             <a:extLst xmlns:a="http://schemas.openxmlformats.org/drawingml/2006/main">
               <a:ext uri="{FF2B5EF4-FFF2-40B4-BE49-F238E27FC236}">
-                <a16:creationId xmlns:a16="http://schemas.microsoft.com/office/drawing/2014/main" id="{77CB9E96-AEF9-411B-BEC9-6359AA303815}"/>
+                <a16:creationId xmlns:a16="http://schemas.microsoft.com/office/drawing/2014/main" id="{1D983110-6EDD-40BD-BFAD-375F299AD468}"/>
               </a:ext>
             </a:extLst>
           </p:cNvPr>
@@ -11979,7 +11910,7 @@
           <p:cNvPr id="13" name="">
             <a:extLst xmlns:a="http://schemas.openxmlformats.org/drawingml/2006/main">
               <a:ext uri="{FF2B5EF4-FFF2-40B4-BE49-F238E27FC236}">
-                <a16:creationId xmlns:a16="http://schemas.microsoft.com/office/drawing/2014/main" id="{8B96C8FD-1B7B-4427-9654-4F56CB8DB1B5}"/>
+                <a16:creationId xmlns:a16="http://schemas.microsoft.com/office/drawing/2014/main" id="{1B678197-A281-439F-B659-D8E59D67EA04}"/>
               </a:ext>
             </a:extLst>
           </p:cNvPr>
@@ -12035,7 +11966,7 @@
           <p:cNvPr id="14" name="">
             <a:extLst xmlns:a="http://schemas.openxmlformats.org/drawingml/2006/main">
               <a:ext uri="{FF2B5EF4-FFF2-40B4-BE49-F238E27FC236}">
-                <a16:creationId xmlns:a16="http://schemas.microsoft.com/office/drawing/2014/main" id="{105D374B-63BB-450C-A08A-6BBA3B2A1AC8}"/>
+                <a16:creationId xmlns:a16="http://schemas.microsoft.com/office/drawing/2014/main" id="{60E4839B-23DD-42A8-8ED5-FBE46479729D}"/>
               </a:ext>
             </a:extLst>
           </p:cNvPr>
@@ -12091,7 +12022,7 @@
           <p:cNvPr id="15" name="">
             <a:extLst xmlns:a="http://schemas.openxmlformats.org/drawingml/2006/main">
               <a:ext uri="{FF2B5EF4-FFF2-40B4-BE49-F238E27FC236}">
-                <a16:creationId xmlns:a16="http://schemas.microsoft.com/office/drawing/2014/main" id="{171D08A2-0130-48D7-AE5B-84ACB4682904}"/>
+                <a16:creationId xmlns:a16="http://schemas.microsoft.com/office/drawing/2014/main" id="{C9743112-CE11-4ED8-85E0-06B6DAA3ABDF}"/>
               </a:ext>
             </a:extLst>
           </p:cNvPr>
@@ -12147,7 +12078,7 @@
           <p:cNvPr id="16" name="">
             <a:extLst xmlns:a="http://schemas.openxmlformats.org/drawingml/2006/main">
               <a:ext uri="{FF2B5EF4-FFF2-40B4-BE49-F238E27FC236}">
-                <a16:creationId xmlns:a16="http://schemas.microsoft.com/office/drawing/2014/main" id="{E1D48DAC-2C49-463C-BE79-C1A23B927738}"/>
+                <a16:creationId xmlns:a16="http://schemas.microsoft.com/office/drawing/2014/main" id="{7F3A3042-DD39-4A68-81E6-3C3815A0C49C}"/>
               </a:ext>
             </a:extLst>
           </p:cNvPr>
@@ -12203,7 +12134,7 @@
           <p:cNvPr id="17" name="">
             <a:extLst xmlns:a="http://schemas.openxmlformats.org/drawingml/2006/main">
               <a:ext uri="{FF2B5EF4-FFF2-40B4-BE49-F238E27FC236}">
-                <a16:creationId xmlns:a16="http://schemas.microsoft.com/office/drawing/2014/main" id="{1186ED89-CA23-466B-8604-7890D30FE9E1}"/>
+                <a16:creationId xmlns:a16="http://schemas.microsoft.com/office/drawing/2014/main" id="{3E5FE7E3-162A-40A9-B970-29F7B8D659DA}"/>
               </a:ext>
             </a:extLst>
           </p:cNvPr>
@@ -12234,7 +12165,7 @@
           <p:cNvPr id="18" name="source-footer">
             <a:extLst xmlns:a="http://schemas.openxmlformats.org/drawingml/2006/main">
               <a:ext uri="{FF2B5EF4-FFF2-40B4-BE49-F238E27FC236}">
-                <a16:creationId xmlns:a16="http://schemas.microsoft.com/office/drawing/2014/main" id="{66727C19-075F-4F33-A64F-7EC461DB2CDA}"/>
+                <a16:creationId xmlns:a16="http://schemas.microsoft.com/office/drawing/2014/main" id="{C487868C-11E0-46EF-AEBA-C6566BA355BD}"/>
               </a:ext>
             </a:extLst>
           </p:cNvPr>
@@ -12290,7 +12221,7 @@
           <p:cNvPr id="19" name="slide-number">
             <a:extLst xmlns:a="http://schemas.openxmlformats.org/drawingml/2006/main">
               <a:ext uri="{FF2B5EF4-FFF2-40B4-BE49-F238E27FC236}">
-                <a16:creationId xmlns:a16="http://schemas.microsoft.com/office/drawing/2014/main" id="{F451FFAA-457D-488C-B75B-A33AC7DEA8FC}"/>
+                <a16:creationId xmlns:a16="http://schemas.microsoft.com/office/drawing/2014/main" id="{FBE04D63-4471-46B9-AC29-D475047B6EEA}"/>
               </a:ext>
             </a:extLst>
           </p:cNvPr>
@@ -12344,7 +12275,7 @@
     </p:spTree>
     <p:extLst>
       <p:ext uri="{BB962C8B-B14F-4D97-AF65-F5344CB8AC3E}">
-        <p14:creationId xmlns:p14="http://schemas.microsoft.com/office/powerpoint/2010/main" val="722293340"/>
+        <p14:creationId xmlns:p14="http://schemas.microsoft.com/office/powerpoint/2010/main" val="439031463"/>
       </p:ext>
     </p:extLst>
   </p:cSld>
@@ -12375,7 +12306,7 @@
           <p:cNvPr id="30" name="slide-title">
             <a:extLst xmlns:a="http://schemas.openxmlformats.org/drawingml/2006/main">
               <a:ext uri="{FF2B5EF4-FFF2-40B4-BE49-F238E27FC236}">
-                <a16:creationId xmlns:a16="http://schemas.microsoft.com/office/drawing/2014/main" id="{9F480A15-0A04-447E-879B-4A9B6C51F3DA}"/>
+                <a16:creationId xmlns:a16="http://schemas.microsoft.com/office/drawing/2014/main" id="{5B2DAF16-B2BF-4AB4-A1E1-D1723B234F4C}"/>
               </a:ext>
             </a:extLst>
           </p:cNvPr>
@@ -12431,7 +12362,7 @@
           <p:cNvPr id="2" name="">
             <a:extLst xmlns:a="http://schemas.openxmlformats.org/drawingml/2006/main">
               <a:ext uri="{FF2B5EF4-FFF2-40B4-BE49-F238E27FC236}">
-                <a16:creationId xmlns:a16="http://schemas.microsoft.com/office/drawing/2014/main" id="{819A3ABC-0C92-4F5E-8F89-B373118190A4}"/>
+                <a16:creationId xmlns:a16="http://schemas.microsoft.com/office/drawing/2014/main" id="{A56D977B-2075-4D80-98AA-CE1D4E454C1A}"/>
               </a:ext>
             </a:extLst>
           </p:cNvPr>
@@ -12462,7 +12393,7 @@
           <p:cNvPr id="3" name="">
             <a:extLst xmlns:a="http://schemas.openxmlformats.org/drawingml/2006/main">
               <a:ext uri="{FF2B5EF4-FFF2-40B4-BE49-F238E27FC236}">
-                <a16:creationId xmlns:a16="http://schemas.microsoft.com/office/drawing/2014/main" id="{49E27954-2B40-47D5-A51A-D648D4681505}"/>
+                <a16:creationId xmlns:a16="http://schemas.microsoft.com/office/drawing/2014/main" id="{13464B8D-8B6C-4D88-8674-D85B1DE65980}"/>
               </a:ext>
             </a:extLst>
           </p:cNvPr>
@@ -12518,7 +12449,7 @@
           <p:cNvPr id="4" name="q4-step-1">
             <a:extLst xmlns:a="http://schemas.openxmlformats.org/drawingml/2006/main">
               <a:ext uri="{FF2B5EF4-FFF2-40B4-BE49-F238E27FC236}">
-                <a16:creationId xmlns:a16="http://schemas.microsoft.com/office/drawing/2014/main" id="{BF1ACAF6-E071-4364-9345-CF048A9B8DE3}"/>
+                <a16:creationId xmlns:a16="http://schemas.microsoft.com/office/drawing/2014/main" id="{06AAE7EA-A862-4277-B415-DE91BEBD35FC}"/>
               </a:ext>
             </a:extLst>
           </p:cNvPr>
@@ -12553,7 +12484,7 @@
           <p:cNvPr id="5" name="q4-step-2">
             <a:extLst xmlns:a="http://schemas.openxmlformats.org/drawingml/2006/main">
               <a:ext uri="{FF2B5EF4-FFF2-40B4-BE49-F238E27FC236}">
-                <a16:creationId xmlns:a16="http://schemas.microsoft.com/office/drawing/2014/main" id="{D05AEA24-E434-4E1D-9CE6-B41337BE6DD4}"/>
+                <a16:creationId xmlns:a16="http://schemas.microsoft.com/office/drawing/2014/main" id="{E223E0F9-1C7C-482B-BA98-01474470A14F}"/>
               </a:ext>
             </a:extLst>
           </p:cNvPr>
@@ -12588,7 +12519,7 @@
           <p:cNvPr id="6" name="q4-step-3">
             <a:extLst xmlns:a="http://schemas.openxmlformats.org/drawingml/2006/main">
               <a:ext uri="{FF2B5EF4-FFF2-40B4-BE49-F238E27FC236}">
-                <a16:creationId xmlns:a16="http://schemas.microsoft.com/office/drawing/2014/main" id="{FE49DB80-2D8D-4025-96A8-439BBD42D8F7}"/>
+                <a16:creationId xmlns:a16="http://schemas.microsoft.com/office/drawing/2014/main" id="{966EB7C5-DA18-4337-B29B-F6025DD69620}"/>
               </a:ext>
             </a:extLst>
           </p:cNvPr>
@@ -12675,7 +12606,7 @@
           <p:cNvPr id="9" name="">
             <a:extLst xmlns:a="http://schemas.openxmlformats.org/drawingml/2006/main">
               <a:ext uri="{FF2B5EF4-FFF2-40B4-BE49-F238E27FC236}">
-                <a16:creationId xmlns:a16="http://schemas.microsoft.com/office/drawing/2014/main" id="{B393EC7C-56A7-467F-B594-D8C77A973CA3}"/>
+                <a16:creationId xmlns:a16="http://schemas.microsoft.com/office/drawing/2014/main" id="{222B683A-9388-4ADB-B25C-3ECBF02F3188}"/>
               </a:ext>
             </a:extLst>
           </p:cNvPr>
@@ -12735,7 +12666,7 @@
           <p:cNvPr id="10" name="">
             <a:extLst xmlns:a="http://schemas.openxmlformats.org/drawingml/2006/main">
               <a:ext uri="{FF2B5EF4-FFF2-40B4-BE49-F238E27FC236}">
-                <a16:creationId xmlns:a16="http://schemas.microsoft.com/office/drawing/2014/main" id="{1682F286-B90C-4404-9593-B0AB1452DDC5}"/>
+                <a16:creationId xmlns:a16="http://schemas.microsoft.com/office/drawing/2014/main" id="{B2B3CEA4-A671-46F6-9725-894DC7D88E2B}"/>
               </a:ext>
             </a:extLst>
           </p:cNvPr>
@@ -12791,7 +12722,7 @@
           <p:cNvPr id="11" name="">
             <a:extLst xmlns:a="http://schemas.openxmlformats.org/drawingml/2006/main">
               <a:ext uri="{FF2B5EF4-FFF2-40B4-BE49-F238E27FC236}">
-                <a16:creationId xmlns:a16="http://schemas.microsoft.com/office/drawing/2014/main" id="{80580466-4B3B-4325-B4A7-F65E67590B20}"/>
+                <a16:creationId xmlns:a16="http://schemas.microsoft.com/office/drawing/2014/main" id="{550F59B8-59AF-445C-B46D-D398ACD0EB23}"/>
               </a:ext>
             </a:extLst>
           </p:cNvPr>
@@ -12847,7 +12778,7 @@
           <p:cNvPr id="12" name="">
             <a:extLst xmlns:a="http://schemas.openxmlformats.org/drawingml/2006/main">
               <a:ext uri="{FF2B5EF4-FFF2-40B4-BE49-F238E27FC236}">
-                <a16:creationId xmlns:a16="http://schemas.microsoft.com/office/drawing/2014/main" id="{B3ADC94C-0FFD-444E-A20B-8673C8F0E446}"/>
+                <a16:creationId xmlns:a16="http://schemas.microsoft.com/office/drawing/2014/main" id="{7A19CEC3-1457-4D1F-9D2E-9A44DC4C41AC}"/>
               </a:ext>
             </a:extLst>
           </p:cNvPr>
@@ -12907,7 +12838,7 @@
           <p:cNvPr id="13" name="">
             <a:extLst xmlns:a="http://schemas.openxmlformats.org/drawingml/2006/main">
               <a:ext uri="{FF2B5EF4-FFF2-40B4-BE49-F238E27FC236}">
-                <a16:creationId xmlns:a16="http://schemas.microsoft.com/office/drawing/2014/main" id="{A859D60B-2693-44A6-9B5C-4728C855E6D2}"/>
+                <a16:creationId xmlns:a16="http://schemas.microsoft.com/office/drawing/2014/main" id="{5EB00B45-5190-4B75-B21E-85F37E0F6377}"/>
               </a:ext>
             </a:extLst>
           </p:cNvPr>
@@ -12963,7 +12894,7 @@
           <p:cNvPr id="14" name="">
             <a:extLst xmlns:a="http://schemas.openxmlformats.org/drawingml/2006/main">
               <a:ext uri="{FF2B5EF4-FFF2-40B4-BE49-F238E27FC236}">
-                <a16:creationId xmlns:a16="http://schemas.microsoft.com/office/drawing/2014/main" id="{4F3E6B5A-F13D-426F-90D5-0EA0C4A3C0BD}"/>
+                <a16:creationId xmlns:a16="http://schemas.microsoft.com/office/drawing/2014/main" id="{0230F9F7-6AEC-4DCE-BB57-F604E1EAEAE8}"/>
               </a:ext>
             </a:extLst>
           </p:cNvPr>
@@ -13019,7 +12950,7 @@
           <p:cNvPr id="15" name="">
             <a:extLst xmlns:a="http://schemas.openxmlformats.org/drawingml/2006/main">
               <a:ext uri="{FF2B5EF4-FFF2-40B4-BE49-F238E27FC236}">
-                <a16:creationId xmlns:a16="http://schemas.microsoft.com/office/drawing/2014/main" id="{0C319F72-CC1C-4B82-A953-524572FD028D}"/>
+                <a16:creationId xmlns:a16="http://schemas.microsoft.com/office/drawing/2014/main" id="{D6072D2A-0030-41AA-8EE3-5A312202D0DB}"/>
               </a:ext>
             </a:extLst>
           </p:cNvPr>
@@ -13079,7 +13010,7 @@
           <p:cNvPr id="16" name="">
             <a:extLst xmlns:a="http://schemas.openxmlformats.org/drawingml/2006/main">
               <a:ext uri="{FF2B5EF4-FFF2-40B4-BE49-F238E27FC236}">
-                <a16:creationId xmlns:a16="http://schemas.microsoft.com/office/drawing/2014/main" id="{6FC76CF5-59EA-43D9-86DE-67C5B59B55C2}"/>
+                <a16:creationId xmlns:a16="http://schemas.microsoft.com/office/drawing/2014/main" id="{1385BDC3-2A1A-41A7-A117-C3D566FB024F}"/>
               </a:ext>
             </a:extLst>
           </p:cNvPr>
@@ -13135,7 +13066,7 @@
           <p:cNvPr id="17" name="">
             <a:extLst xmlns:a="http://schemas.openxmlformats.org/drawingml/2006/main">
               <a:ext uri="{FF2B5EF4-FFF2-40B4-BE49-F238E27FC236}">
-                <a16:creationId xmlns:a16="http://schemas.microsoft.com/office/drawing/2014/main" id="{4868DA0F-C0E7-48FE-B1B9-657FAE7D51B6}"/>
+                <a16:creationId xmlns:a16="http://schemas.microsoft.com/office/drawing/2014/main" id="{9B4A155D-BE05-497C-AFC9-2F3ED906D79B}"/>
               </a:ext>
             </a:extLst>
           </p:cNvPr>
@@ -13191,7 +13122,7 @@
           <p:cNvPr id="18" name="">
             <a:extLst xmlns:a="http://schemas.openxmlformats.org/drawingml/2006/main">
               <a:ext uri="{FF2B5EF4-FFF2-40B4-BE49-F238E27FC236}">
-                <a16:creationId xmlns:a16="http://schemas.microsoft.com/office/drawing/2014/main" id="{E6BD3C2B-8254-4B03-ACB1-FE7C77D9C5F9}"/>
+                <a16:creationId xmlns:a16="http://schemas.microsoft.com/office/drawing/2014/main" id="{8A0F6455-15A7-420A-AADA-6026A264F116}"/>
               </a:ext>
             </a:extLst>
           </p:cNvPr>
@@ -13247,7 +13178,7 @@
           <p:cNvPr id="19" name="">
             <a:extLst xmlns:a="http://schemas.openxmlformats.org/drawingml/2006/main">
               <a:ext uri="{FF2B5EF4-FFF2-40B4-BE49-F238E27FC236}">
-                <a16:creationId xmlns:a16="http://schemas.microsoft.com/office/drawing/2014/main" id="{1D8C428E-3540-495C-8025-6032CD2AFB2A}"/>
+                <a16:creationId xmlns:a16="http://schemas.microsoft.com/office/drawing/2014/main" id="{6354138D-EF58-44C2-A4D6-637D8D3771F7}"/>
               </a:ext>
             </a:extLst>
           </p:cNvPr>
@@ -13303,7 +13234,7 @@
           <p:cNvPr id="20" name="">
             <a:extLst xmlns:a="http://schemas.openxmlformats.org/drawingml/2006/main">
               <a:ext uri="{FF2B5EF4-FFF2-40B4-BE49-F238E27FC236}">
-                <a16:creationId xmlns:a16="http://schemas.microsoft.com/office/drawing/2014/main" id="{BC7C6881-DF59-4AEE-BB9C-ECAB5F6FDF69}"/>
+                <a16:creationId xmlns:a16="http://schemas.microsoft.com/office/drawing/2014/main" id="{8C5AD04B-2231-42A3-B99D-DB8ECEA1AEB7}"/>
               </a:ext>
             </a:extLst>
           </p:cNvPr>
@@ -13359,7 +13290,7 @@
           <p:cNvPr id="21" name="">
             <a:extLst xmlns:a="http://schemas.openxmlformats.org/drawingml/2006/main">
               <a:ext uri="{FF2B5EF4-FFF2-40B4-BE49-F238E27FC236}">
-                <a16:creationId xmlns:a16="http://schemas.microsoft.com/office/drawing/2014/main" id="{B64AE299-BCFE-4E98-BED3-58B2063BE8A5}"/>
+                <a16:creationId xmlns:a16="http://schemas.microsoft.com/office/drawing/2014/main" id="{ACA69423-8CDC-4B82-908B-9B507F3692D4}"/>
               </a:ext>
             </a:extLst>
           </p:cNvPr>
@@ -13415,7 +13346,7 @@
           <p:cNvPr id="22" name="">
             <a:extLst xmlns:a="http://schemas.openxmlformats.org/drawingml/2006/main">
               <a:ext uri="{FF2B5EF4-FFF2-40B4-BE49-F238E27FC236}">
-                <a16:creationId xmlns:a16="http://schemas.microsoft.com/office/drawing/2014/main" id="{F9325E55-F67C-4B3C-AE7E-53F3A651FC5F}"/>
+                <a16:creationId xmlns:a16="http://schemas.microsoft.com/office/drawing/2014/main" id="{5BE14785-F4EB-4F3E-A07D-D5A77F1924EA}"/>
               </a:ext>
             </a:extLst>
           </p:cNvPr>
@@ -13471,7 +13402,7 @@
           <p:cNvPr id="23" name="">
             <a:extLst xmlns:a="http://schemas.openxmlformats.org/drawingml/2006/main">
               <a:ext uri="{FF2B5EF4-FFF2-40B4-BE49-F238E27FC236}">
-                <a16:creationId xmlns:a16="http://schemas.microsoft.com/office/drawing/2014/main" id="{4A190C03-F177-40AF-92A8-DB3F2FF796FD}"/>
+                <a16:creationId xmlns:a16="http://schemas.microsoft.com/office/drawing/2014/main" id="{3A3B48F1-6A74-4BA6-AF57-C29C6A13CD03}"/>
               </a:ext>
             </a:extLst>
           </p:cNvPr>
@@ -13527,7 +13458,7 @@
           <p:cNvPr id="24" name="">
             <a:extLst xmlns:a="http://schemas.openxmlformats.org/drawingml/2006/main">
               <a:ext uri="{FF2B5EF4-FFF2-40B4-BE49-F238E27FC236}">
-                <a16:creationId xmlns:a16="http://schemas.microsoft.com/office/drawing/2014/main" id="{9483B845-DE22-4C52-AD9C-D4BD09A1E8F9}"/>
+                <a16:creationId xmlns:a16="http://schemas.microsoft.com/office/drawing/2014/main" id="{8DDE42B6-47B7-4416-84FB-3B2106A57380}"/>
               </a:ext>
             </a:extLst>
           </p:cNvPr>
@@ -13583,7 +13514,7 @@
           <p:cNvPr id="25" name="">
             <a:extLst xmlns:a="http://schemas.openxmlformats.org/drawingml/2006/main">
               <a:ext uri="{FF2B5EF4-FFF2-40B4-BE49-F238E27FC236}">
-                <a16:creationId xmlns:a16="http://schemas.microsoft.com/office/drawing/2014/main" id="{C5C99726-F257-47E5-BD5C-AF740E8F726B}"/>
+                <a16:creationId xmlns:a16="http://schemas.microsoft.com/office/drawing/2014/main" id="{9D4DCDC0-EB41-4FA8-B0A5-0184EF6F8367}"/>
               </a:ext>
             </a:extLst>
           </p:cNvPr>
@@ -13639,7 +13570,7 @@
           <p:cNvPr id="26" name="">
             <a:extLst xmlns:a="http://schemas.openxmlformats.org/drawingml/2006/main">
               <a:ext uri="{FF2B5EF4-FFF2-40B4-BE49-F238E27FC236}">
-                <a16:creationId xmlns:a16="http://schemas.microsoft.com/office/drawing/2014/main" id="{AB627904-1819-491A-B7F9-58D753E78E7A}"/>
+                <a16:creationId xmlns:a16="http://schemas.microsoft.com/office/drawing/2014/main" id="{9E6CFFA9-19F2-46F8-9627-43A85145EEE4}"/>
               </a:ext>
             </a:extLst>
           </p:cNvPr>
@@ -13699,7 +13630,7 @@
           <p:cNvPr id="27" name="">
             <a:extLst xmlns:a="http://schemas.openxmlformats.org/drawingml/2006/main">
               <a:ext uri="{FF2B5EF4-FFF2-40B4-BE49-F238E27FC236}">
-                <a16:creationId xmlns:a16="http://schemas.microsoft.com/office/drawing/2014/main" id="{CB073DDF-8C0B-4C4A-B1DB-2C85FBB6CF51}"/>
+                <a16:creationId xmlns:a16="http://schemas.microsoft.com/office/drawing/2014/main" id="{CE1CDD72-2547-436F-BC87-66717E4CAE82}"/>
               </a:ext>
             </a:extLst>
           </p:cNvPr>
@@ -13730,7 +13661,7 @@
           <p:cNvPr id="28" name="source-footer">
             <a:extLst xmlns:a="http://schemas.openxmlformats.org/drawingml/2006/main">
               <a:ext uri="{FF2B5EF4-FFF2-40B4-BE49-F238E27FC236}">
-                <a16:creationId xmlns:a16="http://schemas.microsoft.com/office/drawing/2014/main" id="{A18C710D-CDD6-476F-B28D-C86A825B4422}"/>
+                <a16:creationId xmlns:a16="http://schemas.microsoft.com/office/drawing/2014/main" id="{8AE2BB2E-B084-4E9F-A464-AA8026BB5930}"/>
               </a:ext>
             </a:extLst>
           </p:cNvPr>
@@ -13786,7 +13717,7 @@
           <p:cNvPr id="29" name="slide-number">
             <a:extLst xmlns:a="http://schemas.openxmlformats.org/drawingml/2006/main">
               <a:ext uri="{FF2B5EF4-FFF2-40B4-BE49-F238E27FC236}">
-                <a16:creationId xmlns:a16="http://schemas.microsoft.com/office/drawing/2014/main" id="{2E192579-274A-4D59-A7B8-401D6C507D0E}"/>
+                <a16:creationId xmlns:a16="http://schemas.microsoft.com/office/drawing/2014/main" id="{974D3BC6-E394-49D6-BEAB-70D0ED797C3E}"/>
               </a:ext>
             </a:extLst>
           </p:cNvPr>
@@ -13840,7 +13771,7 @@
     </p:spTree>
     <p:extLst>
       <p:ext uri="{BB962C8B-B14F-4D97-AF65-F5344CB8AC3E}">
-        <p14:creationId xmlns:p14="http://schemas.microsoft.com/office/powerpoint/2010/main" val="1664319369"/>
+        <p14:creationId xmlns:p14="http://schemas.microsoft.com/office/powerpoint/2010/main" val="1135566230"/>
       </p:ext>
     </p:extLst>
   </p:cSld>
@@ -13871,7 +13802,7 @@
           <p:cNvPr id="17" name="slide-title">
             <a:extLst xmlns:a="http://schemas.openxmlformats.org/drawingml/2006/main">
               <a:ext uri="{FF2B5EF4-FFF2-40B4-BE49-F238E27FC236}">
-                <a16:creationId xmlns:a16="http://schemas.microsoft.com/office/drawing/2014/main" id="{ACA5B515-0569-4E76-AEAD-C4721754B7D8}"/>
+                <a16:creationId xmlns:a16="http://schemas.microsoft.com/office/drawing/2014/main" id="{1452B853-E565-4ED4-A8C0-F06B41B85B82}"/>
               </a:ext>
             </a:extLst>
           </p:cNvPr>
@@ -13927,7 +13858,7 @@
           <p:cNvPr id="2" name="">
             <a:extLst xmlns:a="http://schemas.openxmlformats.org/drawingml/2006/main">
               <a:ext uri="{FF2B5EF4-FFF2-40B4-BE49-F238E27FC236}">
-                <a16:creationId xmlns:a16="http://schemas.microsoft.com/office/drawing/2014/main" id="{904AE88C-0488-4F7A-B736-DEA95D894619}"/>
+                <a16:creationId xmlns:a16="http://schemas.microsoft.com/office/drawing/2014/main" id="{A9AE38A4-1C1C-4F37-ABED-7A9652216A20}"/>
               </a:ext>
             </a:extLst>
           </p:cNvPr>
@@ -13958,7 +13889,7 @@
           <p:cNvPr id="3" name="">
             <a:extLst xmlns:a="http://schemas.openxmlformats.org/drawingml/2006/main">
               <a:ext uri="{FF2B5EF4-FFF2-40B4-BE49-F238E27FC236}">
-                <a16:creationId xmlns:a16="http://schemas.microsoft.com/office/drawing/2014/main" id="{B912594F-EF8F-4C83-ADE2-3D6F76738990}"/>
+                <a16:creationId xmlns:a16="http://schemas.microsoft.com/office/drawing/2014/main" id="{0682F379-7819-44E1-8DCE-13CD2E7621BA}"/>
               </a:ext>
             </a:extLst>
           </p:cNvPr>
@@ -13991,7 +13922,7 @@
           <p:cNvPr id="4" name="">
             <a:extLst xmlns:a="http://schemas.openxmlformats.org/drawingml/2006/main">
               <a:ext uri="{FF2B5EF4-FFF2-40B4-BE49-F238E27FC236}">
-                <a16:creationId xmlns:a16="http://schemas.microsoft.com/office/drawing/2014/main" id="{13142198-F3D7-415C-9B07-61918EB101CF}"/>
+                <a16:creationId xmlns:a16="http://schemas.microsoft.com/office/drawing/2014/main" id="{5BE6E185-1E13-439D-BE7C-5875C7BDF977}"/>
               </a:ext>
             </a:extLst>
           </p:cNvPr>
@@ -14047,7 +13978,7 @@
           <p:cNvPr id="5" name="">
             <a:extLst xmlns:a="http://schemas.openxmlformats.org/drawingml/2006/main">
               <a:ext uri="{FF2B5EF4-FFF2-40B4-BE49-F238E27FC236}">
-                <a16:creationId xmlns:a16="http://schemas.microsoft.com/office/drawing/2014/main" id="{29E02BCC-282C-4F49-8A4D-C3CAD51763F9}"/>
+                <a16:creationId xmlns:a16="http://schemas.microsoft.com/office/drawing/2014/main" id="{3FBE317C-6713-472D-8479-2420B2EC9A3A}"/>
               </a:ext>
             </a:extLst>
           </p:cNvPr>
@@ -14126,7 +14057,7 @@
           <p:cNvPr id="6" name="">
             <a:extLst xmlns:a="http://schemas.openxmlformats.org/drawingml/2006/main">
               <a:ext uri="{FF2B5EF4-FFF2-40B4-BE49-F238E27FC236}">
-                <a16:creationId xmlns:a16="http://schemas.microsoft.com/office/drawing/2014/main" id="{2E34B05F-AA90-4F6F-A7D1-E3EADD673426}"/>
+                <a16:creationId xmlns:a16="http://schemas.microsoft.com/office/drawing/2014/main" id="{D803C304-9A3A-43A5-88F3-B1AE710D1AC7}"/>
               </a:ext>
             </a:extLst>
           </p:cNvPr>
@@ -14159,7 +14090,7 @@
           <p:cNvPr id="7" name="">
             <a:extLst xmlns:a="http://schemas.openxmlformats.org/drawingml/2006/main">
               <a:ext uri="{FF2B5EF4-FFF2-40B4-BE49-F238E27FC236}">
-                <a16:creationId xmlns:a16="http://schemas.microsoft.com/office/drawing/2014/main" id="{D09B33C1-893B-4B3D-9C7A-708B8613F59D}"/>
+                <a16:creationId xmlns:a16="http://schemas.microsoft.com/office/drawing/2014/main" id="{FCA04F91-FE9B-452E-9E3D-EF2A6BF06E12}"/>
               </a:ext>
             </a:extLst>
           </p:cNvPr>
@@ -14215,7 +14146,7 @@
           <p:cNvPr id="8" name="">
             <a:extLst xmlns:a="http://schemas.openxmlformats.org/drawingml/2006/main">
               <a:ext uri="{FF2B5EF4-FFF2-40B4-BE49-F238E27FC236}">
-                <a16:creationId xmlns:a16="http://schemas.microsoft.com/office/drawing/2014/main" id="{A1C9EAD8-CD75-4BE3-B13A-572C66235933}"/>
+                <a16:creationId xmlns:a16="http://schemas.microsoft.com/office/drawing/2014/main" id="{C05F01E5-CC80-4BAE-8981-141E8C843CA9}"/>
               </a:ext>
             </a:extLst>
           </p:cNvPr>
@@ -14294,7 +14225,7 @@
           <p:cNvPr id="9" name="">
             <a:extLst xmlns:a="http://schemas.openxmlformats.org/drawingml/2006/main">
               <a:ext uri="{FF2B5EF4-FFF2-40B4-BE49-F238E27FC236}">
-                <a16:creationId xmlns:a16="http://schemas.microsoft.com/office/drawing/2014/main" id="{8A07A043-A5D3-4F97-BF20-F34A03B37F63}"/>
+                <a16:creationId xmlns:a16="http://schemas.microsoft.com/office/drawing/2014/main" id="{4F00AC33-7C2A-4153-A9AB-F5BD0C482BCF}"/>
               </a:ext>
             </a:extLst>
           </p:cNvPr>
@@ -14350,7 +14281,7 @@
           <p:cNvPr id="10" name="">
             <a:extLst xmlns:a="http://schemas.openxmlformats.org/drawingml/2006/main">
               <a:ext uri="{FF2B5EF4-FFF2-40B4-BE49-F238E27FC236}">
-                <a16:creationId xmlns:a16="http://schemas.microsoft.com/office/drawing/2014/main" id="{3799FFF1-3D7E-4866-A002-5AAAEA957A8E}"/>
+                <a16:creationId xmlns:a16="http://schemas.microsoft.com/office/drawing/2014/main" id="{E76797BC-448C-40DC-93D5-FC0E9B70A5B7}"/>
               </a:ext>
             </a:extLst>
           </p:cNvPr>
@@ -14406,7 +14337,7 @@
           <p:cNvPr id="11" name="">
             <a:extLst xmlns:a="http://schemas.openxmlformats.org/drawingml/2006/main">
               <a:ext uri="{FF2B5EF4-FFF2-40B4-BE49-F238E27FC236}">
-                <a16:creationId xmlns:a16="http://schemas.microsoft.com/office/drawing/2014/main" id="{E64021D4-3D89-4309-8CBC-E01B20649F13}"/>
+                <a16:creationId xmlns:a16="http://schemas.microsoft.com/office/drawing/2014/main" id="{F1B6F811-5B42-454E-9D65-2AD0D24B21D7}"/>
               </a:ext>
             </a:extLst>
           </p:cNvPr>
@@ -14462,7 +14393,7 @@
           <p:cNvPr id="12" name="">
             <a:extLst xmlns:a="http://schemas.openxmlformats.org/drawingml/2006/main">
               <a:ext uri="{FF2B5EF4-FFF2-40B4-BE49-F238E27FC236}">
-                <a16:creationId xmlns:a16="http://schemas.microsoft.com/office/drawing/2014/main" id="{E0302A7D-E215-471B-90C6-F9A91C4C3116}"/>
+                <a16:creationId xmlns:a16="http://schemas.microsoft.com/office/drawing/2014/main" id="{E85C2578-FE7B-4985-AA9A-3563DF0A1BEC}"/>
               </a:ext>
             </a:extLst>
           </p:cNvPr>
@@ -14518,7 +14449,7 @@
           <p:cNvPr id="13" name="">
             <a:extLst xmlns:a="http://schemas.openxmlformats.org/drawingml/2006/main">
               <a:ext uri="{FF2B5EF4-FFF2-40B4-BE49-F238E27FC236}">
-                <a16:creationId xmlns:a16="http://schemas.microsoft.com/office/drawing/2014/main" id="{1C336E51-261C-4E04-9CDA-CDFBEADDD4CB}"/>
+                <a16:creationId xmlns:a16="http://schemas.microsoft.com/office/drawing/2014/main" id="{60DFADBB-6B34-4D5F-AF27-5D62E45511C0}"/>
               </a:ext>
             </a:extLst>
           </p:cNvPr>
@@ -14574,7 +14505,7 @@
           <p:cNvPr id="14" name="">
             <a:extLst xmlns:a="http://schemas.openxmlformats.org/drawingml/2006/main">
               <a:ext uri="{FF2B5EF4-FFF2-40B4-BE49-F238E27FC236}">
-                <a16:creationId xmlns:a16="http://schemas.microsoft.com/office/drawing/2014/main" id="{57C5C5C9-1641-40DE-8E8E-EA83C6C6B632}"/>
+                <a16:creationId xmlns:a16="http://schemas.microsoft.com/office/drawing/2014/main" id="{5A36F070-1802-4E03-BAE2-25C997F98D89}"/>
               </a:ext>
             </a:extLst>
           </p:cNvPr>
@@ -14605,7 +14536,7 @@
           <p:cNvPr id="15" name="source-footer">
             <a:extLst xmlns:a="http://schemas.openxmlformats.org/drawingml/2006/main">
               <a:ext uri="{FF2B5EF4-FFF2-40B4-BE49-F238E27FC236}">
-                <a16:creationId xmlns:a16="http://schemas.microsoft.com/office/drawing/2014/main" id="{A5902862-BEAF-46AF-8484-038E5403C0D5}"/>
+                <a16:creationId xmlns:a16="http://schemas.microsoft.com/office/drawing/2014/main" id="{A247A944-BB46-4B08-8E4B-6B37E4924CF3}"/>
               </a:ext>
             </a:extLst>
           </p:cNvPr>
@@ -14661,7 +14592,7 @@
           <p:cNvPr id="16" name="slide-number">
             <a:extLst xmlns:a="http://schemas.openxmlformats.org/drawingml/2006/main">
               <a:ext uri="{FF2B5EF4-FFF2-40B4-BE49-F238E27FC236}">
-                <a16:creationId xmlns:a16="http://schemas.microsoft.com/office/drawing/2014/main" id="{13C4DE65-88B7-4510-AE98-F0CE1E593D86}"/>
+                <a16:creationId xmlns:a16="http://schemas.microsoft.com/office/drawing/2014/main" id="{8B7C32F8-4983-4C9E-AAFF-58CF4212441E}"/>
               </a:ext>
             </a:extLst>
           </p:cNvPr>
@@ -14715,7 +14646,7 @@
     </p:spTree>
     <p:extLst>
       <p:ext uri="{BB962C8B-B14F-4D97-AF65-F5344CB8AC3E}">
-        <p14:creationId xmlns:p14="http://schemas.microsoft.com/office/powerpoint/2010/main" val="1730916701"/>
+        <p14:creationId xmlns:p14="http://schemas.microsoft.com/office/powerpoint/2010/main" val="1114700855"/>
       </p:ext>
     </p:extLst>
   </p:cSld>
@@ -14746,7 +14677,7 @@
           <p:cNvPr id="8" name="slide-title">
             <a:extLst xmlns:a="http://schemas.openxmlformats.org/drawingml/2006/main">
               <a:ext uri="{FF2B5EF4-FFF2-40B4-BE49-F238E27FC236}">
-                <a16:creationId xmlns:a16="http://schemas.microsoft.com/office/drawing/2014/main" id="{E10B98B2-AF3A-41ED-84B3-927987D8D5F0}"/>
+                <a16:creationId xmlns:a16="http://schemas.microsoft.com/office/drawing/2014/main" id="{2BB072E6-FF59-4BB2-A1D9-9DFAF71277D4}"/>
               </a:ext>
             </a:extLst>
           </p:cNvPr>
@@ -14792,7 +14723,7 @@
                 <a:ea typeface="Aptos Display"/>
                 <a:cs typeface="Aptos Display"/>
               </a:rPr>
-              <a:t>Selected-policy results include full 95% confidence intervals</a:t>
+              <a:t>Full 95% confidence intervals for selected policies</a:t>
             </a:r>
           </a:p>
         </p:txBody>
@@ -14802,7 +14733,7 @@
           <p:cNvPr id="2" name="backup-label">
             <a:extLst xmlns:a="http://schemas.openxmlformats.org/drawingml/2006/main">
               <a:ext uri="{FF2B5EF4-FFF2-40B4-BE49-F238E27FC236}">
-                <a16:creationId xmlns:a16="http://schemas.microsoft.com/office/drawing/2014/main" id="{889D8B6F-B8FD-4B42-8D4B-4715C54ABC62}"/>
+                <a16:creationId xmlns:a16="http://schemas.microsoft.com/office/drawing/2014/main" id="{7BE2DAA1-9E66-422A-B746-9266284968F4}"/>
               </a:ext>
             </a:extLst>
           </p:cNvPr>
@@ -14862,7 +14793,7 @@
           <p:cNvPr id="3" name="">
             <a:extLst xmlns:a="http://schemas.openxmlformats.org/drawingml/2006/main">
               <a:ext uri="{FF2B5EF4-FFF2-40B4-BE49-F238E27FC236}">
-                <a16:creationId xmlns:a16="http://schemas.microsoft.com/office/drawing/2014/main" id="{F70C4D07-D2D6-4170-A49C-9F6367913BB3}"/>
+                <a16:creationId xmlns:a16="http://schemas.microsoft.com/office/drawing/2014/main" id="{8AA0C3BE-B85E-4D51-9A6A-22E08C198AA3}"/>
               </a:ext>
             </a:extLst>
           </p:cNvPr>
@@ -15465,7 +15396,7 @@
           <p:cNvPr id="5" name="">
             <a:extLst xmlns:a="http://schemas.openxmlformats.org/drawingml/2006/main">
               <a:ext uri="{FF2B5EF4-FFF2-40B4-BE49-F238E27FC236}">
-                <a16:creationId xmlns:a16="http://schemas.microsoft.com/office/drawing/2014/main" id="{43040516-8E3C-40B8-8444-F8CD2583B842}"/>
+                <a16:creationId xmlns:a16="http://schemas.microsoft.com/office/drawing/2014/main" id="{6F3DF9EC-6308-4D7C-8141-99B6A82721FC}"/>
               </a:ext>
             </a:extLst>
           </p:cNvPr>
@@ -15496,7 +15427,7 @@
           <p:cNvPr id="6" name="source-footer">
             <a:extLst xmlns:a="http://schemas.openxmlformats.org/drawingml/2006/main">
               <a:ext uri="{FF2B5EF4-FFF2-40B4-BE49-F238E27FC236}">
-                <a16:creationId xmlns:a16="http://schemas.microsoft.com/office/drawing/2014/main" id="{788E422A-7CF4-40AA-AB3D-454F57D6825B}"/>
+                <a16:creationId xmlns:a16="http://schemas.microsoft.com/office/drawing/2014/main" id="{9554DD52-B2D8-41EB-BF4C-D63BE1C657B4}"/>
               </a:ext>
             </a:extLst>
           </p:cNvPr>
@@ -15552,7 +15483,7 @@
           <p:cNvPr id="7" name="slide-number">
             <a:extLst xmlns:a="http://schemas.openxmlformats.org/drawingml/2006/main">
               <a:ext uri="{FF2B5EF4-FFF2-40B4-BE49-F238E27FC236}">
-                <a16:creationId xmlns:a16="http://schemas.microsoft.com/office/drawing/2014/main" id="{1AF2217A-FF78-467A-9577-FAD72019E585}"/>
+                <a16:creationId xmlns:a16="http://schemas.microsoft.com/office/drawing/2014/main" id="{AF0624A7-7875-4EF5-AEB8-E27B10B692F3}"/>
               </a:ext>
             </a:extLst>
           </p:cNvPr>
@@ -15606,7 +15537,7 @@
     </p:spTree>
     <p:extLst>
       <p:ext uri="{BB962C8B-B14F-4D97-AF65-F5344CB8AC3E}">
-        <p14:creationId xmlns:p14="http://schemas.microsoft.com/office/powerpoint/2010/main" val="1527403453"/>
+        <p14:creationId xmlns:p14="http://schemas.microsoft.com/office/powerpoint/2010/main" val="1222444689"/>
       </p:ext>
     </p:extLst>
   </p:cSld>

</xml_diff>